<commit_message>
docs: add XSD Schema introduction slides to handover PPT
Generated with [Claude Code](https://claude.ai/code)
via [Happy](https://happy.engineering)

Co-Authored-By: Claude <noreply@anthropic.com>
Co-Authored-By: Happy <yesreply@happy.engineering>
</commit_message>
<xml_diff>
--- a/floxml_tools_工作交接.pptx
+++ b/floxml_tools_工作交接.pptx
@@ -18,6 +18,8 @@
     <p:sldId id="266" r:id="rId17"/>
     <p:sldId id="267" r:id="rId18"/>
     <p:sldId id="268" r:id="rId19"/>
+    <p:sldId id="269" r:id="rId20"/>
+    <p:sldId id="270" r:id="rId21"/>
   </p:sldIdLst>
   <p:sldSz cx="12191695" cy="6858000" type="screen4x3"/>
   <p:notesSz cx="6858000" cy="9144000"/>
@@ -5722,6 +5724,121 @@
             <a:avLst/>
           </a:prstGeom>
           <a:solidFill>
+            <a:srgbClr val="34495E"/>
+          </a:solidFill>
+          <a:ln>
+            <a:noFill/>
+          </a:ln>
+        </p:spPr>
+        <p:style>
+          <a:lnRef idx="1">
+            <a:schemeClr val="accent1"/>
+          </a:lnRef>
+          <a:fillRef idx="3">
+            <a:schemeClr val="accent1"/>
+          </a:fillRef>
+          <a:effectRef idx="2">
+            <a:schemeClr val="accent1"/>
+          </a:effectRef>
+          <a:fontRef idx="minor">
+            <a:schemeClr val="lt1"/>
+          </a:fontRef>
+        </p:style>
+        <p:txBody>
+          <a:bodyPr rtlCol="0" anchor="ctr"/>
+          <a:lstStyle/>
+          <a:p>
+            <a:pPr algn="ctr"/>
+          </a:p>
+        </p:txBody>
+      </p:sp>
+      <p:sp>
+        <p:nvSpPr>
+          <p:cNvPr id="3" name="TextBox 2"/>
+          <p:cNvSpPr txBox="1"/>
+          <p:nvPr/>
+        </p:nvSpPr>
+        <p:spPr>
+          <a:xfrm>
+            <a:off x="548640" y="274320"/>
+            <a:ext cx="10972800" cy="640080"/>
+          </a:xfrm>
+          <a:prstGeom prst="rect">
+            <a:avLst/>
+          </a:prstGeom>
+          <a:noFill/>
+        </p:spPr>
+        <p:txBody>
+          <a:bodyPr wrap="square">
+            <a:spAutoFit/>
+          </a:bodyPr>
+          <a:lstStyle/>
+          <a:p>
+            <a:pPr algn="l">
+              <a:defRPr sz="3200" b="1">
+                <a:solidFill>
+                  <a:srgbClr val="1B3A5C"/>
+                </a:solidFill>
+                <a:latin typeface="Microsoft YaHei"/>
+              </a:defRPr>
+            </a:pPr>
+            <a:r>
+              <a:t>FloXML XSD Schema 参考文档</a:t>
+            </a:r>
+          </a:p>
+        </p:txBody>
+      </p:sp>
+      <p:sp>
+        <p:nvSpPr>
+          <p:cNvPr id="4" name="TextBox 3"/>
+          <p:cNvSpPr txBox="1"/>
+          <p:nvPr/>
+        </p:nvSpPr>
+        <p:spPr>
+          <a:xfrm>
+            <a:off x="548640" y="1005840"/>
+            <a:ext cx="10972800" cy="365760"/>
+          </a:xfrm>
+          <a:prstGeom prst="rect">
+            <a:avLst/>
+          </a:prstGeom>
+          <a:noFill/>
+        </p:spPr>
+        <p:txBody>
+          <a:bodyPr wrap="square">
+            <a:spAutoFit/>
+          </a:bodyPr>
+          <a:lstStyle/>
+          <a:p>
+            <a:pPr algn="l">
+              <a:defRPr sz="1400" b="0">
+                <a:solidFill>
+                  <a:srgbClr val="666666"/>
+                </a:solidFill>
+                <a:latin typeface="Microsoft YaHei"/>
+              </a:defRPr>
+            </a:pPr>
+            <a:r>
+              <a:t>examples/DCIM Development Toolkit/Schema Files/FloXML/ — 4,001 行 XSD 定义了 FloXML 完整结构规范。</a:t>
+            </a:r>
+          </a:p>
+        </p:txBody>
+      </p:sp>
+      <p:sp>
+        <p:nvSpPr>
+          <p:cNvPr id="5" name="Rectangle 4"/>
+          <p:cNvSpPr/>
+          <p:nvPr/>
+        </p:nvSpPr>
+        <p:spPr>
+          <a:xfrm>
+            <a:off x="365760" y="1554480"/>
+            <a:ext cx="2103120" cy="411480"/>
+          </a:xfrm>
+          <a:prstGeom prst="rect">
+            <a:avLst/>
+          </a:prstGeom>
+          <a:solidFill>
             <a:srgbClr val="2E75B6"/>
           </a:solidFill>
           <a:ln>
@@ -5752,14 +5869,93 @@
       </p:sp>
       <p:sp>
         <p:nvSpPr>
-          <p:cNvPr id="3" name="TextBox 2"/>
-          <p:cNvSpPr txBox="1"/>
-          <p:nvPr/>
-        </p:nvSpPr>
-        <p:spPr>
-          <a:xfrm>
-            <a:off x="548640" y="274320"/>
-            <a:ext cx="10972800" cy="640080"/>
+          <p:cNvPr id="6" name="TextBox 5"/>
+          <p:cNvSpPr txBox="1"/>
+          <p:nvPr/>
+        </p:nvSpPr>
+        <p:spPr>
+          <a:xfrm>
+            <a:off x="411480" y="1600200"/>
+            <a:ext cx="2011680" cy="320040"/>
+          </a:xfrm>
+          <a:prstGeom prst="rect">
+            <a:avLst/>
+          </a:prstGeom>
+          <a:noFill/>
+        </p:spPr>
+        <p:txBody>
+          <a:bodyPr wrap="square">
+            <a:spAutoFit/>
+          </a:bodyPr>
+          <a:lstStyle/>
+          <a:p>
+            <a:pPr algn="ctr">
+              <a:defRPr sz="1100" b="1">
+                <a:solidFill>
+                  <a:srgbClr val="FFFFFF"/>
+                </a:solidFill>
+                <a:latin typeface="Microsoft YaHei"/>
+              </a:defRPr>
+            </a:pPr>
+            <a:r>
+              <a:t>主入口  (140 行)</a:t>
+            </a:r>
+          </a:p>
+        </p:txBody>
+      </p:sp>
+      <p:sp>
+        <p:nvSpPr>
+          <p:cNvPr id="7" name="Rectangle 6"/>
+          <p:cNvSpPr/>
+          <p:nvPr/>
+        </p:nvSpPr>
+        <p:spPr>
+          <a:xfrm>
+            <a:off x="365760" y="1965960"/>
+            <a:ext cx="2103120" cy="3611880"/>
+          </a:xfrm>
+          <a:prstGeom prst="rect">
+            <a:avLst/>
+          </a:prstGeom>
+          <a:solidFill>
+            <a:srgbClr val="F2F2F2"/>
+          </a:solidFill>
+          <a:ln>
+            <a:noFill/>
+          </a:ln>
+        </p:spPr>
+        <p:style>
+          <a:lnRef idx="1">
+            <a:schemeClr val="accent1"/>
+          </a:lnRef>
+          <a:fillRef idx="3">
+            <a:schemeClr val="accent1"/>
+          </a:fillRef>
+          <a:effectRef idx="2">
+            <a:schemeClr val="accent1"/>
+          </a:effectRef>
+          <a:fontRef idx="minor">
+            <a:schemeClr val="lt1"/>
+          </a:fontRef>
+        </p:style>
+        <p:txBody>
+          <a:bodyPr rtlCol="0" anchor="ctr"/>
+          <a:lstStyle/>
+          <a:p>
+            <a:pPr algn="ctr"/>
+          </a:p>
+        </p:txBody>
+      </p:sp>
+      <p:sp>
+        <p:nvSpPr>
+          <p:cNvPr id="8" name="TextBox 7"/>
+          <p:cNvSpPr txBox="1"/>
+          <p:nvPr/>
+        </p:nvSpPr>
+        <p:spPr>
+          <a:xfrm>
+            <a:off x="438912" y="2057400"/>
+            <a:ext cx="1956816" cy="365760"/>
           </a:xfrm>
           <a:prstGeom prst="rect">
             <a:avLst/>
@@ -5773,29 +5969,921 @@
           <a:lstStyle/>
           <a:p>
             <a:pPr algn="l">
-              <a:defRPr sz="3200" b="1">
-                <a:solidFill>
-                  <a:srgbClr val="1B3A5C"/>
-                </a:solidFill>
-                <a:latin typeface="Microsoft YaHei"/>
-              </a:defRPr>
-            </a:pPr>
-            <a:r>
-              <a:t>交接总结</a:t>
-            </a:r>
-          </a:p>
-        </p:txBody>
-      </p:sp>
-      <p:sp>
-        <p:nvSpPr>
-          <p:cNvPr id="4" name="Rectangle 3"/>
+              <a:defRPr sz="1000" b="1">
+                <a:solidFill>
+                  <a:srgbClr val="2E75B6"/>
+                </a:solidFill>
+                <a:latin typeface="Menlo"/>
+              </a:defRPr>
+            </a:pPr>
+            <a:r>
+              <a:t>xmlSchema.xsd</a:t>
+            </a:r>
+          </a:p>
+        </p:txBody>
+      </p:sp>
+      <p:sp>
+        <p:nvSpPr>
+          <p:cNvPr id="9" name="TextBox 8"/>
+          <p:cNvSpPr txBox="1"/>
+          <p:nvPr/>
+        </p:nvSpPr>
+        <p:spPr>
+          <a:xfrm>
+            <a:off x="438912" y="2468880"/>
+            <a:ext cx="1956816" cy="3017520"/>
+          </a:xfrm>
+          <a:prstGeom prst="rect">
+            <a:avLst/>
+          </a:prstGeom>
+          <a:noFill/>
+        </p:spPr>
+        <p:txBody>
+          <a:bodyPr wrap="square">
+            <a:spAutoFit/>
+          </a:bodyPr>
+          <a:lstStyle/>
+          <a:p>
+            <a:pPr algn="l">
+              <a:defRPr sz="1000" b="0">
+                <a:solidFill>
+                  <a:srgbClr val="333333"/>
+                </a:solidFill>
+                <a:latin typeface="Microsoft YaHei"/>
+              </a:defRPr>
+            </a:pPr>
+            <a:r>
+              <a:t>定义 &lt;xml_case&gt; 根元素</a:t>
+            </a:r>
+            <a:br/>
+            <a:r>
+              <a:t>model / solve / grid /</a:t>
+            </a:r>
+            <a:br/>
+            <a:r>
+              <a:t>attributes / geometry /</a:t>
+            </a:r>
+            <a:br/>
+            <a:r>
+              <a:t>solution_domain 的</a:t>
+            </a:r>
+            <a:br/>
+            <a:r>
+              <a:t>嵌套顺序</a:t>
+            </a:r>
+          </a:p>
+        </p:txBody>
+      </p:sp>
+      <p:sp>
+        <p:nvSpPr>
+          <p:cNvPr id="10" name="Rectangle 9"/>
           <p:cNvSpPr/>
           <p:nvPr/>
         </p:nvSpPr>
         <p:spPr>
           <a:xfrm>
-            <a:off x="457200" y="1188720"/>
-            <a:ext cx="11064240" cy="1371600"/>
+            <a:off x="2578608" y="1554480"/>
+            <a:ext cx="2103120" cy="411480"/>
+          </a:xfrm>
+          <a:prstGeom prst="rect">
+            <a:avLst/>
+          </a:prstGeom>
+          <a:solidFill>
+            <a:srgbClr val="5B9BD5"/>
+          </a:solidFill>
+          <a:ln>
+            <a:noFill/>
+          </a:ln>
+        </p:spPr>
+        <p:style>
+          <a:lnRef idx="1">
+            <a:schemeClr val="accent1"/>
+          </a:lnRef>
+          <a:fillRef idx="3">
+            <a:schemeClr val="accent1"/>
+          </a:fillRef>
+          <a:effectRef idx="2">
+            <a:schemeClr val="accent1"/>
+          </a:effectRef>
+          <a:fontRef idx="minor">
+            <a:schemeClr val="lt1"/>
+          </a:fontRef>
+        </p:style>
+        <p:txBody>
+          <a:bodyPr rtlCol="0" anchor="ctr"/>
+          <a:lstStyle/>
+          <a:p>
+            <a:pPr algn="ctr"/>
+          </a:p>
+        </p:txBody>
+      </p:sp>
+      <p:sp>
+        <p:nvSpPr>
+          <p:cNvPr id="11" name="TextBox 10"/>
+          <p:cNvSpPr txBox="1"/>
+          <p:nvPr/>
+        </p:nvSpPr>
+        <p:spPr>
+          <a:xfrm>
+            <a:off x="2624328" y="1600200"/>
+            <a:ext cx="2011680" cy="320040"/>
+          </a:xfrm>
+          <a:prstGeom prst="rect">
+            <a:avLst/>
+          </a:prstGeom>
+          <a:noFill/>
+        </p:spPr>
+        <p:txBody>
+          <a:bodyPr wrap="square">
+            <a:spAutoFit/>
+          </a:bodyPr>
+          <a:lstStyle/>
+          <a:p>
+            <a:pPr algn="ctr">
+              <a:defRPr sz="1100" b="1">
+                <a:solidFill>
+                  <a:srgbClr val="FFFFFF"/>
+                </a:solidFill>
+                <a:latin typeface="Microsoft YaHei"/>
+              </a:defRPr>
+            </a:pPr>
+            <a:r>
+              <a:t>公共类型  (331 行)</a:t>
+            </a:r>
+          </a:p>
+        </p:txBody>
+      </p:sp>
+      <p:sp>
+        <p:nvSpPr>
+          <p:cNvPr id="12" name="Rectangle 11"/>
+          <p:cNvSpPr/>
+          <p:nvPr/>
+        </p:nvSpPr>
+        <p:spPr>
+          <a:xfrm>
+            <a:off x="2578608" y="1965960"/>
+            <a:ext cx="2103120" cy="3611880"/>
+          </a:xfrm>
+          <a:prstGeom prst="rect">
+            <a:avLst/>
+          </a:prstGeom>
+          <a:solidFill>
+            <a:srgbClr val="F2F2F2"/>
+          </a:solidFill>
+          <a:ln>
+            <a:noFill/>
+          </a:ln>
+        </p:spPr>
+        <p:style>
+          <a:lnRef idx="1">
+            <a:schemeClr val="accent1"/>
+          </a:lnRef>
+          <a:fillRef idx="3">
+            <a:schemeClr val="accent1"/>
+          </a:fillRef>
+          <a:effectRef idx="2">
+            <a:schemeClr val="accent1"/>
+          </a:effectRef>
+          <a:fontRef idx="minor">
+            <a:schemeClr val="lt1"/>
+          </a:fontRef>
+        </p:style>
+        <p:txBody>
+          <a:bodyPr rtlCol="0" anchor="ctr"/>
+          <a:lstStyle/>
+          <a:p>
+            <a:pPr algn="ctr"/>
+          </a:p>
+        </p:txBody>
+      </p:sp>
+      <p:sp>
+        <p:nvSpPr>
+          <p:cNvPr id="13" name="TextBox 12"/>
+          <p:cNvSpPr txBox="1"/>
+          <p:nvPr/>
+        </p:nvSpPr>
+        <p:spPr>
+          <a:xfrm>
+            <a:off x="2651760" y="2057400"/>
+            <a:ext cx="1956816" cy="365760"/>
+          </a:xfrm>
+          <a:prstGeom prst="rect">
+            <a:avLst/>
+          </a:prstGeom>
+          <a:noFill/>
+        </p:spPr>
+        <p:txBody>
+          <a:bodyPr wrap="square">
+            <a:spAutoFit/>
+          </a:bodyPr>
+          <a:lstStyle/>
+          <a:p>
+            <a:pPr algn="l">
+              <a:defRPr sz="1000" b="1">
+                <a:solidFill>
+                  <a:srgbClr val="5B9BD5"/>
+                </a:solidFill>
+                <a:latin typeface="Menlo"/>
+              </a:defRPr>
+            </a:pPr>
+            <a:r>
+              <a:t>XmlDefinitions.xsd</a:t>
+            </a:r>
+          </a:p>
+        </p:txBody>
+      </p:sp>
+      <p:sp>
+        <p:nvSpPr>
+          <p:cNvPr id="14" name="TextBox 13"/>
+          <p:cNvSpPr txBox="1"/>
+          <p:nvPr/>
+        </p:nvSpPr>
+        <p:spPr>
+          <a:xfrm>
+            <a:off x="2651760" y="2468880"/>
+            <a:ext cx="1956816" cy="3017520"/>
+          </a:xfrm>
+          <a:prstGeom prst="rect">
+            <a:avLst/>
+          </a:prstGeom>
+          <a:noFill/>
+        </p:spPr>
+        <p:txBody>
+          <a:bodyPr wrap="square">
+            <a:spAutoFit/>
+          </a:bodyPr>
+          <a:lstStyle/>
+          <a:p>
+            <a:pPr algn="l">
+              <a:defRPr sz="1000" b="0">
+                <a:solidFill>
+                  <a:srgbClr val="333333"/>
+                </a:solidFill>
+                <a:latin typeface="Microsoft YaHei"/>
+              </a:defRPr>
+            </a:pPr>
+            <a:r>
+              <a:t>基础类型库:</a:t>
+            </a:r>
+            <a:br/>
+            <a:r>
+              <a:t>triplet / direction /</a:t>
+            </a:r>
+            <a:br/>
+            <a:r>
+              <a:t>trueFalse / ratio /</a:t>
+            </a:r>
+            <a:br/>
+            <a:r>
+              <a:t>variable_types 等</a:t>
+            </a:r>
+            <a:br/>
+            <a:r>
+              <a:t>枚举值定义</a:t>
+            </a:r>
+          </a:p>
+        </p:txBody>
+      </p:sp>
+      <p:sp>
+        <p:nvSpPr>
+          <p:cNvPr id="15" name="Rectangle 14"/>
+          <p:cNvSpPr/>
+          <p:nvPr/>
+        </p:nvSpPr>
+        <p:spPr>
+          <a:xfrm>
+            <a:off x="4791456" y="1554480"/>
+            <a:ext cx="2103120" cy="411480"/>
+          </a:xfrm>
+          <a:prstGeom prst="rect">
+            <a:avLst/>
+          </a:prstGeom>
+          <a:solidFill>
+            <a:srgbClr val="70AD47"/>
+          </a:solidFill>
+          <a:ln>
+            <a:noFill/>
+          </a:ln>
+        </p:spPr>
+        <p:style>
+          <a:lnRef idx="1">
+            <a:schemeClr val="accent1"/>
+          </a:lnRef>
+          <a:fillRef idx="3">
+            <a:schemeClr val="accent1"/>
+          </a:fillRef>
+          <a:effectRef idx="2">
+            <a:schemeClr val="accent1"/>
+          </a:effectRef>
+          <a:fontRef idx="minor">
+            <a:schemeClr val="lt1"/>
+          </a:fontRef>
+        </p:style>
+        <p:txBody>
+          <a:bodyPr rtlCol="0" anchor="ctr"/>
+          <a:lstStyle/>
+          <a:p>
+            <a:pPr algn="ctr"/>
+          </a:p>
+        </p:txBody>
+      </p:sp>
+      <p:sp>
+        <p:nvSpPr>
+          <p:cNvPr id="16" name="TextBox 15"/>
+          <p:cNvSpPr txBox="1"/>
+          <p:nvPr/>
+        </p:nvSpPr>
+        <p:spPr>
+          <a:xfrm>
+            <a:off x="4837176" y="1600200"/>
+            <a:ext cx="2011680" cy="320040"/>
+          </a:xfrm>
+          <a:prstGeom prst="rect">
+            <a:avLst/>
+          </a:prstGeom>
+          <a:noFill/>
+        </p:spPr>
+        <p:txBody>
+          <a:bodyPr wrap="square">
+            <a:spAutoFit/>
+          </a:bodyPr>
+          <a:lstStyle/>
+          <a:p>
+            <a:pPr algn="ctr">
+              <a:defRPr sz="1100" b="1">
+                <a:solidFill>
+                  <a:srgbClr val="FFFFFF"/>
+                </a:solidFill>
+                <a:latin typeface="Microsoft YaHei"/>
+              </a:defRPr>
+            </a:pPr>
+            <a:r>
+              <a:t>属性定义  (783 行)</a:t>
+            </a:r>
+          </a:p>
+        </p:txBody>
+      </p:sp>
+      <p:sp>
+        <p:nvSpPr>
+          <p:cNvPr id="17" name="Rectangle 16"/>
+          <p:cNvSpPr/>
+          <p:nvPr/>
+        </p:nvSpPr>
+        <p:spPr>
+          <a:xfrm>
+            <a:off x="4791456" y="1965960"/>
+            <a:ext cx="2103120" cy="3611880"/>
+          </a:xfrm>
+          <a:prstGeom prst="rect">
+            <a:avLst/>
+          </a:prstGeom>
+          <a:solidFill>
+            <a:srgbClr val="F2F2F2"/>
+          </a:solidFill>
+          <a:ln>
+            <a:noFill/>
+          </a:ln>
+        </p:spPr>
+        <p:style>
+          <a:lnRef idx="1">
+            <a:schemeClr val="accent1"/>
+          </a:lnRef>
+          <a:fillRef idx="3">
+            <a:schemeClr val="accent1"/>
+          </a:fillRef>
+          <a:effectRef idx="2">
+            <a:schemeClr val="accent1"/>
+          </a:effectRef>
+          <a:fontRef idx="minor">
+            <a:schemeClr val="lt1"/>
+          </a:fontRef>
+        </p:style>
+        <p:txBody>
+          <a:bodyPr rtlCol="0" anchor="ctr"/>
+          <a:lstStyle/>
+          <a:p>
+            <a:pPr algn="ctr"/>
+          </a:p>
+        </p:txBody>
+      </p:sp>
+      <p:sp>
+        <p:nvSpPr>
+          <p:cNvPr id="18" name="TextBox 17"/>
+          <p:cNvSpPr txBox="1"/>
+          <p:nvPr/>
+        </p:nvSpPr>
+        <p:spPr>
+          <a:xfrm>
+            <a:off x="4864608" y="2057400"/>
+            <a:ext cx="1956816" cy="365760"/>
+          </a:xfrm>
+          <a:prstGeom prst="rect">
+            <a:avLst/>
+          </a:prstGeom>
+          <a:noFill/>
+        </p:spPr>
+        <p:txBody>
+          <a:bodyPr wrap="square">
+            <a:spAutoFit/>
+          </a:bodyPr>
+          <a:lstStyle/>
+          <a:p>
+            <a:pPr algn="l">
+              <a:defRPr sz="1000" b="1">
+                <a:solidFill>
+                  <a:srgbClr val="70AD47"/>
+                </a:solidFill>
+                <a:latin typeface="Menlo"/>
+              </a:defRPr>
+            </a:pPr>
+            <a:r>
+              <a:t>XmlAttributes.xsd</a:t>
+            </a:r>
+          </a:p>
+        </p:txBody>
+      </p:sp>
+      <p:sp>
+        <p:nvSpPr>
+          <p:cNvPr id="19" name="TextBox 18"/>
+          <p:cNvSpPr txBox="1"/>
+          <p:nvPr/>
+        </p:nvSpPr>
+        <p:spPr>
+          <a:xfrm>
+            <a:off x="4864608" y="2468880"/>
+            <a:ext cx="1956816" cy="3017520"/>
+          </a:xfrm>
+          <a:prstGeom prst="rect">
+            <a:avLst/>
+          </a:prstGeom>
+          <a:noFill/>
+        </p:spPr>
+        <p:txBody>
+          <a:bodyPr wrap="square">
+            <a:spAutoFit/>
+          </a:bodyPr>
+          <a:lstStyle/>
+          <a:p>
+            <a:pPr algn="l">
+              <a:defRPr sz="1000" b="0">
+                <a:solidFill>
+                  <a:srgbClr val="333333"/>
+                </a:solidFill>
+                <a:latin typeface="Microsoft YaHei"/>
+              </a:defRPr>
+            </a:pPr>
+            <a:r>
+              <a:t>材料 / 热源 / 环境 /</a:t>
+            </a:r>
+            <a:br/>
+            <a:r>
+              <a:t>表面 / 辐射 / 风扇 /</a:t>
+            </a:r>
+            <a:br/>
+            <a:r>
+              <a:t>流阻 / 网格约束 /</a:t>
+            </a:r>
+            <a:br/>
+            <a:r>
+              <a:t>瞬态函数</a:t>
+            </a:r>
+            <a:br/>
+            <a:r>
+              <a:t>每种属性的字段和枚举</a:t>
+            </a:r>
+          </a:p>
+        </p:txBody>
+      </p:sp>
+      <p:sp>
+        <p:nvSpPr>
+          <p:cNvPr id="20" name="Rectangle 19"/>
+          <p:cNvSpPr/>
+          <p:nvPr/>
+        </p:nvSpPr>
+        <p:spPr>
+          <a:xfrm>
+            <a:off x="7004304" y="1554480"/>
+            <a:ext cx="2103120" cy="411480"/>
+          </a:xfrm>
+          <a:prstGeom prst="rect">
+            <a:avLst/>
+          </a:prstGeom>
+          <a:solidFill>
+            <a:srgbClr val="ED7D31"/>
+          </a:solidFill>
+          <a:ln>
+            <a:noFill/>
+          </a:ln>
+        </p:spPr>
+        <p:style>
+          <a:lnRef idx="1">
+            <a:schemeClr val="accent1"/>
+          </a:lnRef>
+          <a:fillRef idx="3">
+            <a:schemeClr val="accent1"/>
+          </a:fillRef>
+          <a:effectRef idx="2">
+            <a:schemeClr val="accent1"/>
+          </a:effectRef>
+          <a:fontRef idx="minor">
+            <a:schemeClr val="lt1"/>
+          </a:fontRef>
+        </p:style>
+        <p:txBody>
+          <a:bodyPr rtlCol="0" anchor="ctr"/>
+          <a:lstStyle/>
+          <a:p>
+            <a:pPr algn="ctr"/>
+          </a:p>
+        </p:txBody>
+      </p:sp>
+      <p:sp>
+        <p:nvSpPr>
+          <p:cNvPr id="21" name="TextBox 20"/>
+          <p:cNvSpPr txBox="1"/>
+          <p:nvPr/>
+        </p:nvSpPr>
+        <p:spPr>
+          <a:xfrm>
+            <a:off x="7050024" y="1600200"/>
+            <a:ext cx="2011680" cy="320040"/>
+          </a:xfrm>
+          <a:prstGeom prst="rect">
+            <a:avLst/>
+          </a:prstGeom>
+          <a:noFill/>
+        </p:spPr>
+        <p:txBody>
+          <a:bodyPr wrap="square">
+            <a:spAutoFit/>
+          </a:bodyPr>
+          <a:lstStyle/>
+          <a:p>
+            <a:pPr algn="ctr">
+              <a:defRPr sz="1100" b="1">
+                <a:solidFill>
+                  <a:srgbClr val="FFFFFF"/>
+                </a:solidFill>
+                <a:latin typeface="Microsoft YaHei"/>
+              </a:defRPr>
+            </a:pPr>
+            <a:r>
+              <a:t>求解/网格  (615 行)</a:t>
+            </a:r>
+          </a:p>
+        </p:txBody>
+      </p:sp>
+      <p:sp>
+        <p:nvSpPr>
+          <p:cNvPr id="22" name="Rectangle 21"/>
+          <p:cNvSpPr/>
+          <p:nvPr/>
+        </p:nvSpPr>
+        <p:spPr>
+          <a:xfrm>
+            <a:off x="7004304" y="1965960"/>
+            <a:ext cx="2103120" cy="3611880"/>
+          </a:xfrm>
+          <a:prstGeom prst="rect">
+            <a:avLst/>
+          </a:prstGeom>
+          <a:solidFill>
+            <a:srgbClr val="F2F2F2"/>
+          </a:solidFill>
+          <a:ln>
+            <a:noFill/>
+          </a:ln>
+        </p:spPr>
+        <p:style>
+          <a:lnRef idx="1">
+            <a:schemeClr val="accent1"/>
+          </a:lnRef>
+          <a:fillRef idx="3">
+            <a:schemeClr val="accent1"/>
+          </a:fillRef>
+          <a:effectRef idx="2">
+            <a:schemeClr val="accent1"/>
+          </a:effectRef>
+          <a:fontRef idx="minor">
+            <a:schemeClr val="lt1"/>
+          </a:fontRef>
+        </p:style>
+        <p:txBody>
+          <a:bodyPr rtlCol="0" anchor="ctr"/>
+          <a:lstStyle/>
+          <a:p>
+            <a:pPr algn="ctr"/>
+          </a:p>
+        </p:txBody>
+      </p:sp>
+      <p:sp>
+        <p:nvSpPr>
+          <p:cNvPr id="23" name="TextBox 22"/>
+          <p:cNvSpPr txBox="1"/>
+          <p:nvPr/>
+        </p:nvSpPr>
+        <p:spPr>
+          <a:xfrm>
+            <a:off x="7077456" y="2057400"/>
+            <a:ext cx="1956816" cy="365760"/>
+          </a:xfrm>
+          <a:prstGeom prst="rect">
+            <a:avLst/>
+          </a:prstGeom>
+          <a:noFill/>
+        </p:spPr>
+        <p:txBody>
+          <a:bodyPr wrap="square">
+            <a:spAutoFit/>
+          </a:bodyPr>
+          <a:lstStyle/>
+          <a:p>
+            <a:pPr algn="l">
+              <a:defRPr sz="1000" b="1">
+                <a:solidFill>
+                  <a:srgbClr val="ED7D31"/>
+                </a:solidFill>
+                <a:latin typeface="Menlo"/>
+              </a:defRPr>
+            </a:pPr>
+            <a:r>
+              <a:t>XmlEntities.xsd</a:t>
+            </a:r>
+          </a:p>
+        </p:txBody>
+      </p:sp>
+      <p:sp>
+        <p:nvSpPr>
+          <p:cNvPr id="24" name="TextBox 23"/>
+          <p:cNvSpPr txBox="1"/>
+          <p:nvPr/>
+        </p:nvSpPr>
+        <p:spPr>
+          <a:xfrm>
+            <a:off x="7077456" y="2468880"/>
+            <a:ext cx="1956816" cy="3017520"/>
+          </a:xfrm>
+          <a:prstGeom prst="rect">
+            <a:avLst/>
+          </a:prstGeom>
+          <a:noFill/>
+        </p:spPr>
+        <p:txBody>
+          <a:bodyPr wrap="square">
+            <a:spAutoFit/>
+          </a:bodyPr>
+          <a:lstStyle/>
+          <a:p>
+            <a:pPr algn="l">
+              <a:defRPr sz="1000" b="0">
+                <a:solidFill>
+                  <a:srgbClr val="333333"/>
+                </a:solidFill>
+                <a:latin typeface="Microsoft YaHei"/>
+              </a:defRPr>
+            </a:pPr>
+            <a:r>
+              <a:t>model 求解模式</a:t>
+            </a:r>
+            <a:br/>
+            <a:r>
+              <a:t>solve 求解器控制</a:t>
+            </a:r>
+            <a:br/>
+            <a:r>
+              <a:t>grid 系统网格</a:t>
+            </a:r>
+            <a:br/>
+            <a:r>
+              <a:t>patches 局部加密</a:t>
+            </a:r>
+            <a:br/>
+            <a:r>
+              <a:t>全部字段和合法值</a:t>
+            </a:r>
+          </a:p>
+        </p:txBody>
+      </p:sp>
+      <p:sp>
+        <p:nvSpPr>
+          <p:cNvPr id="25" name="Rectangle 24"/>
+          <p:cNvSpPr/>
+          <p:nvPr/>
+        </p:nvSpPr>
+        <p:spPr>
+          <a:xfrm>
+            <a:off x="9217152" y="1554480"/>
+            <a:ext cx="2103120" cy="411480"/>
+          </a:xfrm>
+          <a:prstGeom prst="rect">
+            <a:avLst/>
+          </a:prstGeom>
+          <a:solidFill>
+            <a:srgbClr val="8E44AD"/>
+          </a:solidFill>
+          <a:ln>
+            <a:noFill/>
+          </a:ln>
+        </p:spPr>
+        <p:style>
+          <a:lnRef idx="1">
+            <a:schemeClr val="accent1"/>
+          </a:lnRef>
+          <a:fillRef idx="3">
+            <a:schemeClr val="accent1"/>
+          </a:fillRef>
+          <a:effectRef idx="2">
+            <a:schemeClr val="accent1"/>
+          </a:effectRef>
+          <a:fontRef idx="minor">
+            <a:schemeClr val="lt1"/>
+          </a:fontRef>
+        </p:style>
+        <p:txBody>
+          <a:bodyPr rtlCol="0" anchor="ctr"/>
+          <a:lstStyle/>
+          <a:p>
+            <a:pPr algn="ctr"/>
+          </a:p>
+        </p:txBody>
+      </p:sp>
+      <p:sp>
+        <p:nvSpPr>
+          <p:cNvPr id="26" name="TextBox 25"/>
+          <p:cNvSpPr txBox="1"/>
+          <p:nvPr/>
+        </p:nvSpPr>
+        <p:spPr>
+          <a:xfrm>
+            <a:off x="9262872" y="1600200"/>
+            <a:ext cx="2011680" cy="320040"/>
+          </a:xfrm>
+          <a:prstGeom prst="rect">
+            <a:avLst/>
+          </a:prstGeom>
+          <a:noFill/>
+        </p:spPr>
+        <p:txBody>
+          <a:bodyPr wrap="square">
+            <a:spAutoFit/>
+          </a:bodyPr>
+          <a:lstStyle/>
+          <a:p>
+            <a:pPr algn="ctr">
+              <a:defRPr sz="1100" b="1">
+                <a:solidFill>
+                  <a:srgbClr val="FFFFFF"/>
+                </a:solidFill>
+                <a:latin typeface="Microsoft YaHei"/>
+              </a:defRPr>
+            </a:pPr>
+            <a:r>
+              <a:t>几何体  (2,132 行)</a:t>
+            </a:r>
+          </a:p>
+        </p:txBody>
+      </p:sp>
+      <p:sp>
+        <p:nvSpPr>
+          <p:cNvPr id="27" name="Rectangle 26"/>
+          <p:cNvSpPr/>
+          <p:nvPr/>
+        </p:nvSpPr>
+        <p:spPr>
+          <a:xfrm>
+            <a:off x="9217152" y="1965960"/>
+            <a:ext cx="2103120" cy="3611880"/>
+          </a:xfrm>
+          <a:prstGeom prst="rect">
+            <a:avLst/>
+          </a:prstGeom>
+          <a:solidFill>
+            <a:srgbClr val="F2F2F2"/>
+          </a:solidFill>
+          <a:ln>
+            <a:noFill/>
+          </a:ln>
+        </p:spPr>
+        <p:style>
+          <a:lnRef idx="1">
+            <a:schemeClr val="accent1"/>
+          </a:lnRef>
+          <a:fillRef idx="3">
+            <a:schemeClr val="accent1"/>
+          </a:fillRef>
+          <a:effectRef idx="2">
+            <a:schemeClr val="accent1"/>
+          </a:effectRef>
+          <a:fontRef idx="minor">
+            <a:schemeClr val="lt1"/>
+          </a:fontRef>
+        </p:style>
+        <p:txBody>
+          <a:bodyPr rtlCol="0" anchor="ctr"/>
+          <a:lstStyle/>
+          <a:p>
+            <a:pPr algn="ctr"/>
+          </a:p>
+        </p:txBody>
+      </p:sp>
+      <p:sp>
+        <p:nvSpPr>
+          <p:cNvPr id="28" name="TextBox 27"/>
+          <p:cNvSpPr txBox="1"/>
+          <p:nvPr/>
+        </p:nvSpPr>
+        <p:spPr>
+          <a:xfrm>
+            <a:off x="9290304" y="2057400"/>
+            <a:ext cx="1956816" cy="365760"/>
+          </a:xfrm>
+          <a:prstGeom prst="rect">
+            <a:avLst/>
+          </a:prstGeom>
+          <a:noFill/>
+        </p:spPr>
+        <p:txBody>
+          <a:bodyPr wrap="square">
+            <a:spAutoFit/>
+          </a:bodyPr>
+          <a:lstStyle/>
+          <a:p>
+            <a:pPr algn="l">
+              <a:defRPr sz="1000" b="1">
+                <a:solidFill>
+                  <a:srgbClr val="8E44AD"/>
+                </a:solidFill>
+                <a:latin typeface="Menlo"/>
+              </a:defRPr>
+            </a:pPr>
+            <a:r>
+              <a:t>XmlGeometry.xsd</a:t>
+            </a:r>
+          </a:p>
+        </p:txBody>
+      </p:sp>
+      <p:sp>
+        <p:nvSpPr>
+          <p:cNvPr id="29" name="TextBox 28"/>
+          <p:cNvSpPr txBox="1"/>
+          <p:nvPr/>
+        </p:nvSpPr>
+        <p:spPr>
+          <a:xfrm>
+            <a:off x="9290304" y="2468880"/>
+            <a:ext cx="1956816" cy="3017520"/>
+          </a:xfrm>
+          <a:prstGeom prst="rect">
+            <a:avLst/>
+          </a:prstGeom>
+          <a:noFill/>
+        </p:spPr>
+        <p:txBody>
+          <a:bodyPr wrap="square">
+            <a:spAutoFit/>
+          </a:bodyPr>
+          <a:lstStyle/>
+          <a:p>
+            <a:pPr algn="l">
+              <a:defRPr sz="1000" b="0">
+                <a:solidFill>
+                  <a:srgbClr val="333333"/>
+                </a:solidFill>
+                <a:latin typeface="Microsoft YaHei"/>
+              </a:defRPr>
+            </a:pPr>
+            <a:r>
+              <a:t>cuboid / plate / prism /</a:t>
+            </a:r>
+            <a:br/>
+            <a:r>
+              <a:t>assembly / fan / vent /</a:t>
+            </a:r>
+            <a:br/>
+            <a:r>
+              <a:t>source / monitor_point</a:t>
+            </a:r>
+            <a:br/>
+            <a:r>
+              <a:t>每个几何体的字段</a:t>
+            </a:r>
+            <a:br/>
+            <a:r>
+              <a:t>和可引用的属性</a:t>
+            </a:r>
+          </a:p>
+        </p:txBody>
+      </p:sp>
+      <p:sp>
+        <p:nvSpPr>
+          <p:cNvPr id="30" name="Rectangle 29"/>
+          <p:cNvSpPr/>
+          <p:nvPr/>
+        </p:nvSpPr>
+        <p:spPr>
+          <a:xfrm>
+            <a:off x="457200" y="5760720"/>
+            <a:ext cx="5303520" cy="548640"/>
           </a:xfrm>
           <a:prstGeom prst="rect">
             <a:avLst/>
@@ -5831,302 +6919,14 @@
       </p:sp>
       <p:sp>
         <p:nvSpPr>
-          <p:cNvPr id="5" name="TextBox 4"/>
-          <p:cNvSpPr txBox="1"/>
-          <p:nvPr/>
-        </p:nvSpPr>
-        <p:spPr>
-          <a:xfrm>
-            <a:off x="640080" y="1280160"/>
-            <a:ext cx="2560320" cy="640080"/>
-          </a:xfrm>
-          <a:prstGeom prst="rect">
-            <a:avLst/>
-          </a:prstGeom>
-          <a:noFill/>
-        </p:spPr>
-        <p:txBody>
-          <a:bodyPr wrap="square">
-            <a:spAutoFit/>
-          </a:bodyPr>
-          <a:lstStyle/>
-          <a:p>
-            <a:pPr algn="ctr">
-              <a:defRPr sz="3600" b="1">
-                <a:solidFill>
-                  <a:srgbClr val="2E75B6"/>
-                </a:solidFill>
-                <a:latin typeface="Microsoft YaHei"/>
-              </a:defRPr>
-            </a:pPr>
-            <a:r>
-              <a:t>4</a:t>
-            </a:r>
-          </a:p>
-        </p:txBody>
-      </p:sp>
-      <p:sp>
-        <p:nvSpPr>
-          <p:cNvPr id="6" name="TextBox 5"/>
-          <p:cNvSpPr txBox="1"/>
-          <p:nvPr/>
-        </p:nvSpPr>
-        <p:spPr>
-          <a:xfrm>
-            <a:off x="640080" y="1828800"/>
-            <a:ext cx="2560320" cy="365760"/>
-          </a:xfrm>
-          <a:prstGeom prst="rect">
-            <a:avLst/>
-          </a:prstGeom>
-          <a:noFill/>
-        </p:spPr>
-        <p:txBody>
-          <a:bodyPr wrap="square">
-            <a:spAutoFit/>
-          </a:bodyPr>
-          <a:lstStyle/>
-          <a:p>
-            <a:pPr algn="ctr">
-              <a:defRPr sz="1300" b="0">
-                <a:solidFill>
-                  <a:srgbClr val="666666"/>
-                </a:solidFill>
-                <a:latin typeface="Microsoft YaHei"/>
-              </a:defRPr>
-            </a:pPr>
-            <a:r>
-              <a:t>核心 Python 模块</a:t>
-            </a:r>
-          </a:p>
-        </p:txBody>
-      </p:sp>
-      <p:sp>
-        <p:nvSpPr>
-          <p:cNvPr id="7" name="TextBox 6"/>
-          <p:cNvSpPr txBox="1"/>
-          <p:nvPr/>
-        </p:nvSpPr>
-        <p:spPr>
-          <a:xfrm>
-            <a:off x="3383280" y="1280160"/>
-            <a:ext cx="2560320" cy="640080"/>
-          </a:xfrm>
-          <a:prstGeom prst="rect">
-            <a:avLst/>
-          </a:prstGeom>
-          <a:noFill/>
-        </p:spPr>
-        <p:txBody>
-          <a:bodyPr wrap="square">
-            <a:spAutoFit/>
-          </a:bodyPr>
-          <a:lstStyle/>
-          <a:p>
-            <a:pPr algn="ctr">
-              <a:defRPr sz="3600" b="1">
-                <a:solidFill>
-                  <a:srgbClr val="2E75B6"/>
-                </a:solidFill>
-                <a:latin typeface="Microsoft YaHei"/>
-              </a:defRPr>
-            </a:pPr>
-            <a:r>
-              <a:t>~5,200</a:t>
-            </a:r>
-          </a:p>
-        </p:txBody>
-      </p:sp>
-      <p:sp>
-        <p:nvSpPr>
-          <p:cNvPr id="8" name="TextBox 7"/>
-          <p:cNvSpPr txBox="1"/>
-          <p:nvPr/>
-        </p:nvSpPr>
-        <p:spPr>
-          <a:xfrm>
-            <a:off x="3383280" y="1828800"/>
-            <a:ext cx="2560320" cy="365760"/>
-          </a:xfrm>
-          <a:prstGeom prst="rect">
-            <a:avLst/>
-          </a:prstGeom>
-          <a:noFill/>
-        </p:spPr>
-        <p:txBody>
-          <a:bodyPr wrap="square">
-            <a:spAutoFit/>
-          </a:bodyPr>
-          <a:lstStyle/>
-          <a:p>
-            <a:pPr algn="ctr">
-              <a:defRPr sz="1300" b="0">
-                <a:solidFill>
-                  <a:srgbClr val="666666"/>
-                </a:solidFill>
-                <a:latin typeface="Microsoft YaHei"/>
-              </a:defRPr>
-            </a:pPr>
-            <a:r>
-              <a:t>行核心代码</a:t>
-            </a:r>
-          </a:p>
-        </p:txBody>
-      </p:sp>
-      <p:sp>
-        <p:nvSpPr>
-          <p:cNvPr id="9" name="TextBox 8"/>
-          <p:cNvSpPr txBox="1"/>
-          <p:nvPr/>
-        </p:nvSpPr>
-        <p:spPr>
-          <a:xfrm>
-            <a:off x="6126480" y="1280160"/>
-            <a:ext cx="2560320" cy="640080"/>
-          </a:xfrm>
-          <a:prstGeom prst="rect">
-            <a:avLst/>
-          </a:prstGeom>
-          <a:noFill/>
-        </p:spPr>
-        <p:txBody>
-          <a:bodyPr wrap="square">
-            <a:spAutoFit/>
-          </a:bodyPr>
-          <a:lstStyle/>
-          <a:p>
-            <a:pPr algn="ctr">
-              <a:defRPr sz="3600" b="1">
-                <a:solidFill>
-                  <a:srgbClr val="2E75B6"/>
-                </a:solidFill>
-                <a:latin typeface="Microsoft YaHei"/>
-              </a:defRPr>
-            </a:pPr>
-            <a:r>
-              <a:t>6+</a:t>
-            </a:r>
-          </a:p>
-        </p:txBody>
-      </p:sp>
-      <p:sp>
-        <p:nvSpPr>
-          <p:cNvPr id="10" name="TextBox 9"/>
-          <p:cNvSpPr txBox="1"/>
-          <p:nvPr/>
-        </p:nvSpPr>
-        <p:spPr>
-          <a:xfrm>
-            <a:off x="6126480" y="1828800"/>
-            <a:ext cx="2560320" cy="365760"/>
-          </a:xfrm>
-          <a:prstGeom prst="rect">
-            <a:avLst/>
-          </a:prstGeom>
-          <a:noFill/>
-        </p:spPr>
-        <p:txBody>
-          <a:bodyPr wrap="square">
-            <a:spAutoFit/>
-          </a:bodyPr>
-          <a:lstStyle/>
-          <a:p>
-            <a:pPr algn="ctr">
-              <a:defRPr sz="1300" b="0">
-                <a:solidFill>
-                  <a:srgbClr val="666666"/>
-                </a:solidFill>
-                <a:latin typeface="Microsoft YaHei"/>
-              </a:defRPr>
-            </a:pPr>
-            <a:r>
-              <a:t>JSON 配置文件</a:t>
-            </a:r>
-          </a:p>
-        </p:txBody>
-      </p:sp>
-      <p:sp>
-        <p:nvSpPr>
-          <p:cNvPr id="11" name="TextBox 10"/>
-          <p:cNvSpPr txBox="1"/>
-          <p:nvPr/>
-        </p:nvSpPr>
-        <p:spPr>
-          <a:xfrm>
-            <a:off x="8869680" y="1280160"/>
-            <a:ext cx="2560320" cy="640080"/>
-          </a:xfrm>
-          <a:prstGeom prst="rect">
-            <a:avLst/>
-          </a:prstGeom>
-          <a:noFill/>
-        </p:spPr>
-        <p:txBody>
-          <a:bodyPr wrap="square">
-            <a:spAutoFit/>
-          </a:bodyPr>
-          <a:lstStyle/>
-          <a:p>
-            <a:pPr algn="ctr">
-              <a:defRPr sz="3600" b="1">
-                <a:solidFill>
-                  <a:srgbClr val="2E75B6"/>
-                </a:solidFill>
-                <a:latin typeface="Microsoft YaHei"/>
-              </a:defRPr>
-            </a:pPr>
-            <a:r>
-              <a:t>7</a:t>
-            </a:r>
-          </a:p>
-        </p:txBody>
-      </p:sp>
-      <p:sp>
-        <p:nvSpPr>
-          <p:cNvPr id="12" name="TextBox 11"/>
-          <p:cNvSpPr txBox="1"/>
-          <p:nvPr/>
-        </p:nvSpPr>
-        <p:spPr>
-          <a:xfrm>
-            <a:off x="8869680" y="1828800"/>
-            <a:ext cx="2560320" cy="365760"/>
-          </a:xfrm>
-          <a:prstGeom prst="rect">
-            <a:avLst/>
-          </a:prstGeom>
-          <a:noFill/>
-        </p:spPr>
-        <p:txBody>
-          <a:bodyPr wrap="square">
-            <a:spAutoFit/>
-          </a:bodyPr>
-          <a:lstStyle/>
-          <a:p>
-            <a:pPr algn="ctr">
-              <a:defRPr sz="1300" b="0">
-                <a:solidFill>
-                  <a:srgbClr val="666666"/>
-                </a:solidFill>
-                <a:latin typeface="Microsoft YaHei"/>
-              </a:defRPr>
-            </a:pPr>
-            <a:r>
-              <a:t>边界条件类型</a:t>
-            </a:r>
-          </a:p>
-        </p:txBody>
-      </p:sp>
-      <p:sp>
-        <p:nvSpPr>
-          <p:cNvPr id="13" name="TextBox 12"/>
-          <p:cNvSpPr txBox="1"/>
-          <p:nvPr/>
-        </p:nvSpPr>
-        <p:spPr>
-          <a:xfrm>
-            <a:off x="548640" y="2926080"/>
-            <a:ext cx="10972800" cy="365760"/>
+          <p:cNvPr id="31" name="TextBox 30"/>
+          <p:cNvSpPr txBox="1"/>
+          <p:nvPr/>
+        </p:nvSpPr>
+        <p:spPr>
+          <a:xfrm>
+            <a:off x="640080" y="5806440"/>
+            <a:ext cx="4937760" cy="457200"/>
           </a:xfrm>
           <a:prstGeom prst="rect">
             <a:avLst/>
@@ -6140,7 +6940,7 @@
           <a:lstStyle/>
           <a:p>
             <a:pPr algn="l">
-              <a:defRPr sz="2000" b="1">
+              <a:defRPr sz="1200" b="1">
                 <a:solidFill>
                   <a:srgbClr val="1B3A5C"/>
                 </a:solidFill>
@@ -6148,124 +6948,21 @@
               </a:defRPr>
             </a:pPr>
             <a:r>
-              <a:t>核心要点</a:t>
-            </a:r>
-          </a:p>
-        </p:txBody>
-      </p:sp>
-      <p:sp>
-        <p:nvSpPr>
-          <p:cNvPr id="14" name="TextBox 13"/>
-          <p:cNvSpPr txBox="1"/>
-          <p:nvPr/>
-        </p:nvSpPr>
-        <p:spPr>
-          <a:xfrm>
-            <a:off x="548640" y="3383280"/>
-            <a:ext cx="10972800" cy="2286000"/>
-          </a:xfrm>
-          <a:prstGeom prst="rect">
-            <a:avLst/>
-          </a:prstGeom>
-          <a:noFill/>
-        </p:spPr>
-        <p:txBody>
-          <a:bodyPr wrap="square">
-            <a:spAutoFit/>
-          </a:bodyPr>
-          <a:lstStyle/>
-          <a:p>
-            <a:pPr>
-              <a:spcAft>
-                <a:spcPts val="600"/>
-              </a:spcAft>
-              <a:defRPr sz="1400">
-                <a:solidFill>
-                  <a:srgbClr val="333333"/>
-                </a:solidFill>
-                <a:latin typeface="Microsoft YaHei"/>
-              </a:defRPr>
-            </a:pPr>
-            <a:r>
-              <a:t>1. 工作流: FloTHERM 导出 ECXML → ecxml_to_floxml_converter 转换 → 三个 JSON 配置修改 FloXML → 导入求解</a:t>
-            </a:r>
-          </a:p>
-          <a:p>
-            <a:pPr>
-              <a:spcAft>
-                <a:spcPts val="600"/>
-              </a:spcAft>
-              <a:defRPr sz="1400">
-                <a:solidFill>
-                  <a:srgbClr val="333333"/>
-                </a:solidFill>
-                <a:latin typeface="Microsoft YaHei"/>
-              </a:defRPr>
-            </a:pPr>
-            <a:r>
-              <a:t>2. 三个配置修改脚本各司其职: solve_settings / volume_regions / boundary_conditions</a:t>
-            </a:r>
-          </a:p>
-          <a:p>
-            <a:pPr>
-              <a:spcAft>
-                <a:spcPts val="600"/>
-              </a:spcAft>
-              <a:defRPr sz="1400">
-                <a:solidFill>
-                  <a:srgbClr val="333333"/>
-                </a:solidFill>
-                <a:latin typeface="Microsoft YaHei"/>
-              </a:defRPr>
-            </a:pPr>
-            <a:r>
-              <a:t>3. JSON 配置驱动: 修改参数只需改 JSON，不需要手动编辑 XML</a:t>
-            </a:r>
-          </a:p>
-          <a:p>
-            <a:pPr>
-              <a:spcAft>
-                <a:spcPts val="600"/>
-              </a:spcAft>
-              <a:defRPr sz="1400">
-                <a:solidFill>
-                  <a:srgbClr val="333333"/>
-                </a:solidFill>
-                <a:latin typeface="Microsoft YaHei"/>
-              </a:defRPr>
-            </a:pPr>
-            <a:r>
-              <a:t>4. 所有模块都有命令行入口，支持 -h 查看帮助</a:t>
-            </a:r>
-          </a:p>
-          <a:p>
-            <a:pPr>
-              <a:spcAft>
-                <a:spcPts val="600"/>
-              </a:spcAft>
-              <a:defRPr sz="1400">
-                <a:solidFill>
-                  <a:srgbClr val="333333"/>
-                </a:solidFill>
-                <a:latin typeface="Microsoft YaHei"/>
-              </a:defRPr>
-            </a:pPr>
-            <a:r>
-              <a:t>5. 每个模块有完整 docstring，包含用法示例和参数说明</a:t>
-            </a:r>
-          </a:p>
-        </p:txBody>
-      </p:sp>
-      <p:sp>
-        <p:nvSpPr>
-          <p:cNvPr id="15" name="Rectangle 14"/>
+              <a:t>推荐阅读顺序: Definitions → Attributes → Entities → Geometry → Schema</a:t>
+            </a:r>
+          </a:p>
+        </p:txBody>
+      </p:sp>
+      <p:sp>
+        <p:nvSpPr>
+          <p:cNvPr id="32" name="Rectangle 31"/>
           <p:cNvSpPr/>
           <p:nvPr/>
         </p:nvSpPr>
         <p:spPr>
           <a:xfrm>
-            <a:off x="457200" y="5120640"/>
-            <a:ext cx="11064240" cy="1188720"/>
+            <a:off x="6035040" y="5760720"/>
+            <a:ext cx="5486400" cy="548640"/>
           </a:xfrm>
           <a:prstGeom prst="rect">
             <a:avLst/>
@@ -6301,14 +6998,14 @@
       </p:sp>
       <p:sp>
         <p:nvSpPr>
-          <p:cNvPr id="16" name="TextBox 15"/>
-          <p:cNvSpPr txBox="1"/>
-          <p:nvPr/>
-        </p:nvSpPr>
-        <p:spPr>
-          <a:xfrm>
-            <a:off x="640080" y="5212080"/>
-            <a:ext cx="10698480" cy="274320"/>
+          <p:cNvPr id="33" name="TextBox 32"/>
+          <p:cNvSpPr txBox="1"/>
+          <p:nvPr/>
+        </p:nvSpPr>
+        <p:spPr>
+          <a:xfrm>
+            <a:off x="6217920" y="5806440"/>
+            <a:ext cx="5120640" cy="457200"/>
           </a:xfrm>
           <a:prstGeom prst="rect">
             <a:avLst/>
@@ -6322,77 +7019,22 @@
           <a:lstStyle/>
           <a:p>
             <a:pPr algn="l">
-              <a:defRPr sz="1400" b="1">
-                <a:solidFill>
-                  <a:srgbClr val="1B3A5C"/>
-                </a:solidFill>
-                <a:latin typeface="Microsoft YaHei"/>
-              </a:defRPr>
-            </a:pPr>
-            <a:r>
-              <a:t>后续建议</a:t>
-            </a:r>
-          </a:p>
-        </p:txBody>
-      </p:sp>
-      <p:sp>
-        <p:nvSpPr>
-          <p:cNvPr id="17" name="TextBox 16"/>
-          <p:cNvSpPr txBox="1"/>
-          <p:nvPr/>
-        </p:nvSpPr>
-        <p:spPr>
-          <a:xfrm>
-            <a:off x="640080" y="5486400"/>
-            <a:ext cx="10698480" cy="731520"/>
-          </a:xfrm>
-          <a:prstGeom prst="rect">
-            <a:avLst/>
-          </a:prstGeom>
-          <a:noFill/>
-        </p:spPr>
-        <p:txBody>
-          <a:bodyPr wrap="square">
-            <a:spAutoFit/>
-          </a:bodyPr>
-          <a:lstStyle/>
-          <a:p>
-            <a:pPr>
-              <a:spcAft>
-                <a:spcPts val="200"/>
-              </a:spcAft>
-              <a:defRPr sz="1200">
-                <a:solidFill>
-                  <a:srgbClr val="666666"/>
-                </a:solidFill>
-                <a:latin typeface="Microsoft YaHei"/>
-              </a:defRPr>
-            </a:pPr>
-            <a:r>
-              <a:t>• 补充单元测试（目前仅 ecxml_to_floxml_converter 有测试）</a:t>
-            </a:r>
-          </a:p>
-          <a:p>
-            <a:pPr>
-              <a:spcAft>
-                <a:spcPts val="200"/>
-              </a:spcAft>
-              <a:defRPr sz="1200">
-                <a:solidFill>
-                  <a:srgbClr val="666666"/>
-                </a:solidFill>
-                <a:latin typeface="Microsoft YaHei"/>
-              </a:defRPr>
-            </a:pPr>
-            <a:r>
-              <a:t>• 引入 logging 替代 print，便于调试</a:t>
-            </a:r>
-          </a:p>
-        </p:txBody>
-      </p:sp>
-      <p:sp>
-        <p:nvSpPr>
-          <p:cNvPr id="18" name="TextBox 17"/>
+              <a:defRPr sz="1200" b="0">
+                <a:solidFill>
+                  <a:srgbClr val="333333"/>
+                </a:solidFill>
+                <a:latin typeface="Microsoft YaHei"/>
+              </a:defRPr>
+            </a:pPr>
+            <a:r>
+              <a:t>用途: 写 JSON 配置时查 XSD 确认字段名、枚举值、必填/可选</a:t>
+            </a:r>
+          </a:p>
+        </p:txBody>
+      </p:sp>
+      <p:sp>
+        <p:nvSpPr>
+          <p:cNvPr id="34" name="TextBox 33"/>
           <p:cNvSpPr txBox="1"/>
           <p:nvPr/>
         </p:nvSpPr>
@@ -6435,6 +7077,1607 @@
 </file>
 
 <file path=ppt/slides/slide13.xml><?xml version="1.0" encoding="utf-8"?>
+<p:sld xmlns:a="http://schemas.openxmlformats.org/drawingml/2006/main" xmlns:p="http://schemas.openxmlformats.org/presentationml/2006/main" xmlns:r="http://schemas.openxmlformats.org/officeDocument/2006/relationships">
+  <p:cSld>
+    <p:bg>
+      <p:bgPr>
+        <a:solidFill>
+          <a:srgbClr val="FFFFFF"/>
+        </a:solidFill>
+        <a:effectLst/>
+      </p:bgPr>
+    </p:bg>
+    <p:spTree>
+      <p:nvGrpSpPr>
+        <p:cNvPr id="1" name=""/>
+        <p:cNvGrpSpPr/>
+        <p:nvPr/>
+      </p:nvGrpSpPr>
+      <p:grpSpPr/>
+      <p:sp>
+        <p:nvSpPr>
+          <p:cNvPr id="2" name="Rectangle 1"/>
+          <p:cNvSpPr/>
+          <p:nvPr/>
+        </p:nvSpPr>
+        <p:spPr>
+          <a:xfrm>
+            <a:off x="0" y="0"/>
+            <a:ext cx="12191695" cy="73152"/>
+          </a:xfrm>
+          <a:prstGeom prst="rect">
+            <a:avLst/>
+          </a:prstGeom>
+          <a:solidFill>
+            <a:srgbClr val="34495E"/>
+          </a:solidFill>
+          <a:ln>
+            <a:noFill/>
+          </a:ln>
+        </p:spPr>
+        <p:style>
+          <a:lnRef idx="1">
+            <a:schemeClr val="accent1"/>
+          </a:lnRef>
+          <a:fillRef idx="3">
+            <a:schemeClr val="accent1"/>
+          </a:fillRef>
+          <a:effectRef idx="2">
+            <a:schemeClr val="accent1"/>
+          </a:effectRef>
+          <a:fontRef idx="minor">
+            <a:schemeClr val="lt1"/>
+          </a:fontRef>
+        </p:style>
+        <p:txBody>
+          <a:bodyPr rtlCol="0" anchor="ctr"/>
+          <a:lstStyle/>
+          <a:p>
+            <a:pPr algn="ctr"/>
+          </a:p>
+        </p:txBody>
+      </p:sp>
+      <p:sp>
+        <p:nvSpPr>
+          <p:cNvPr id="3" name="TextBox 2"/>
+          <p:cNvSpPr txBox="1"/>
+          <p:nvPr/>
+        </p:nvSpPr>
+        <p:spPr>
+          <a:xfrm>
+            <a:off x="548640" y="274320"/>
+            <a:ext cx="10972800" cy="640080"/>
+          </a:xfrm>
+          <a:prstGeom prst="rect">
+            <a:avLst/>
+          </a:prstGeom>
+          <a:noFill/>
+        </p:spPr>
+        <p:txBody>
+          <a:bodyPr wrap="square">
+            <a:spAutoFit/>
+          </a:bodyPr>
+          <a:lstStyle/>
+          <a:p>
+            <a:pPr algn="l">
+              <a:defRPr sz="3200" b="1">
+                <a:solidFill>
+                  <a:srgbClr val="1B3A5C"/>
+                </a:solidFill>
+                <a:latin typeface="Microsoft YaHei"/>
+              </a:defRPr>
+            </a:pPr>
+            <a:r>
+              <a:t>XSD Schema — 关键内容速查</a:t>
+            </a:r>
+          </a:p>
+        </p:txBody>
+      </p:sp>
+      <p:sp>
+        <p:nvSpPr>
+          <p:cNvPr id="4" name="Rectangle 3"/>
+          <p:cNvSpPr/>
+          <p:nvPr/>
+        </p:nvSpPr>
+        <p:spPr>
+          <a:xfrm>
+            <a:off x="457200" y="1005840"/>
+            <a:ext cx="3657600" cy="5303520"/>
+          </a:xfrm>
+          <a:prstGeom prst="rect">
+            <a:avLst/>
+          </a:prstGeom>
+          <a:solidFill>
+            <a:srgbClr val="F2F2F2"/>
+          </a:solidFill>
+          <a:ln>
+            <a:noFill/>
+          </a:ln>
+        </p:spPr>
+        <p:style>
+          <a:lnRef idx="1">
+            <a:schemeClr val="accent1"/>
+          </a:lnRef>
+          <a:fillRef idx="3">
+            <a:schemeClr val="accent1"/>
+          </a:fillRef>
+          <a:effectRef idx="2">
+            <a:schemeClr val="accent1"/>
+          </a:effectRef>
+          <a:fontRef idx="minor">
+            <a:schemeClr val="lt1"/>
+          </a:fontRef>
+        </p:style>
+        <p:txBody>
+          <a:bodyPr rtlCol="0" anchor="ctr"/>
+          <a:lstStyle/>
+          <a:p>
+            <a:pPr algn="ctr"/>
+          </a:p>
+        </p:txBody>
+      </p:sp>
+      <p:sp>
+        <p:nvSpPr>
+          <p:cNvPr id="5" name="TextBox 4"/>
+          <p:cNvSpPr txBox="1"/>
+          <p:nvPr/>
+        </p:nvSpPr>
+        <p:spPr>
+          <a:xfrm>
+            <a:off x="640080" y="1097280"/>
+            <a:ext cx="3291840" cy="320040"/>
+          </a:xfrm>
+          <a:prstGeom prst="rect">
+            <a:avLst/>
+          </a:prstGeom>
+          <a:noFill/>
+        </p:spPr>
+        <p:txBody>
+          <a:bodyPr wrap="square">
+            <a:spAutoFit/>
+          </a:bodyPr>
+          <a:lstStyle/>
+          <a:p>
+            <a:pPr algn="l">
+              <a:defRPr sz="1400" b="1">
+                <a:solidFill>
+                  <a:srgbClr val="2E75B6"/>
+                </a:solidFill>
+                <a:latin typeface="Microsoft YaHei"/>
+              </a:defRPr>
+            </a:pPr>
+            <a:r>
+              <a:t>xml_case 整体结构</a:t>
+            </a:r>
+          </a:p>
+        </p:txBody>
+      </p:sp>
+      <p:sp>
+        <p:nvSpPr>
+          <p:cNvPr id="6" name="TextBox 5"/>
+          <p:cNvSpPr txBox="1"/>
+          <p:nvPr/>
+        </p:nvSpPr>
+        <p:spPr>
+          <a:xfrm>
+            <a:off x="640080" y="1463040"/>
+            <a:ext cx="3291840" cy="4572000"/>
+          </a:xfrm>
+          <a:prstGeom prst="rect">
+            <a:avLst/>
+          </a:prstGeom>
+          <a:noFill/>
+        </p:spPr>
+        <p:txBody>
+          <a:bodyPr wrap="square">
+            <a:spAutoFit/>
+          </a:bodyPr>
+          <a:lstStyle/>
+          <a:p>
+            <a:pPr algn="l">
+              <a:defRPr sz="1000" b="0">
+                <a:solidFill>
+                  <a:srgbClr val="333333"/>
+                </a:solidFill>
+                <a:latin typeface="Menlo"/>
+              </a:defRPr>
+            </a:pPr>
+            <a:r>
+              <a:t>&lt;xml_case&gt;</a:t>
+            </a:r>
+            <a:br/>
+            <a:r>
+              <a:t>  &lt;name/&gt;             必填</a:t>
+            </a:r>
+            <a:br/>
+            <a:r>
+              <a:t>  &lt;model/&gt;            求解模式</a:t>
+            </a:r>
+            <a:br/>
+            <a:r>
+              <a:t>  &lt;solve/&gt;            求解器</a:t>
+            </a:r>
+            <a:br/>
+            <a:r>
+              <a:t>  &lt;grid/&gt;             网格</a:t>
+            </a:r>
+            <a:br/>
+            <a:r>
+              <a:t>  &lt;attributes&gt;</a:t>
+            </a:r>
+            <a:br/>
+            <a:r>
+              <a:t>    materials         材料库</a:t>
+            </a:r>
+            <a:br/>
+            <a:r>
+              <a:t>    surfaces          表面属性</a:t>
+            </a:r>
+            <a:br/>
+            <a:r>
+              <a:t>    surface_exchanges 表面换热</a:t>
+            </a:r>
+            <a:br/>
+            <a:r>
+              <a:t>    thermals          热模型</a:t>
+            </a:r>
+            <a:br/>
+            <a:r>
+              <a:t>    sources           热源</a:t>
+            </a:r>
+            <a:br/>
+            <a:r>
+              <a:t>    ambients          环境条件</a:t>
+            </a:r>
+            <a:br/>
+            <a:r>
+              <a:t>    fluids            流体</a:t>
+            </a:r>
+            <a:br/>
+            <a:r>
+              <a:t>    grid_constraints  网格约束</a:t>
+            </a:r>
+            <a:br/>
+            <a:r>
+              <a:t>    radiations        辐射模型</a:t>
+            </a:r>
+            <a:br/>
+            <a:r>
+              <a:t>    transients        瞬态函数</a:t>
+            </a:r>
+            <a:br/>
+            <a:r>
+              <a:t>    fans / resistances</a:t>
+            </a:r>
+            <a:br/>
+            <a:r>
+              <a:t>  &lt;/attributes&gt;</a:t>
+            </a:r>
+            <a:br/>
+            <a:r>
+              <a:t>  &lt;geometry/&gt;         几何模型</a:t>
+            </a:r>
+            <a:br/>
+            <a:r>
+              <a:t>  &lt;solution_domain/&gt;  求解域</a:t>
+            </a:r>
+            <a:br/>
+            <a:r>
+              <a:t>&lt;/xml_case&gt;</a:t>
+            </a:r>
+          </a:p>
+        </p:txBody>
+      </p:sp>
+      <p:sp>
+        <p:nvSpPr>
+          <p:cNvPr id="7" name="Rectangle 6"/>
+          <p:cNvSpPr/>
+          <p:nvPr/>
+        </p:nvSpPr>
+        <p:spPr>
+          <a:xfrm>
+            <a:off x="4297680" y="1005840"/>
+            <a:ext cx="3657600" cy="5303520"/>
+          </a:xfrm>
+          <a:prstGeom prst="rect">
+            <a:avLst/>
+          </a:prstGeom>
+          <a:solidFill>
+            <a:srgbClr val="F2F2F2"/>
+          </a:solidFill>
+          <a:ln>
+            <a:noFill/>
+          </a:ln>
+        </p:spPr>
+        <p:style>
+          <a:lnRef idx="1">
+            <a:schemeClr val="accent1"/>
+          </a:lnRef>
+          <a:fillRef idx="3">
+            <a:schemeClr val="accent1"/>
+          </a:fillRef>
+          <a:effectRef idx="2">
+            <a:schemeClr val="accent1"/>
+          </a:effectRef>
+          <a:fontRef idx="minor">
+            <a:schemeClr val="lt1"/>
+          </a:fontRef>
+        </p:style>
+        <p:txBody>
+          <a:bodyPr rtlCol="0" anchor="ctr"/>
+          <a:lstStyle/>
+          <a:p>
+            <a:pPr algn="ctr"/>
+          </a:p>
+        </p:txBody>
+      </p:sp>
+      <p:sp>
+        <p:nvSpPr>
+          <p:cNvPr id="8" name="TextBox 7"/>
+          <p:cNvSpPr txBox="1"/>
+          <p:nvPr/>
+        </p:nvSpPr>
+        <p:spPr>
+          <a:xfrm>
+            <a:off x="4480560" y="1097280"/>
+            <a:ext cx="3291840" cy="320040"/>
+          </a:xfrm>
+          <a:prstGeom prst="rect">
+            <a:avLst/>
+          </a:prstGeom>
+          <a:noFill/>
+        </p:spPr>
+        <p:txBody>
+          <a:bodyPr wrap="square">
+            <a:spAutoFit/>
+          </a:bodyPr>
+          <a:lstStyle/>
+          <a:p>
+            <a:pPr algn="l">
+              <a:defRPr sz="1400" b="1">
+                <a:solidFill>
+                  <a:srgbClr val="70AD47"/>
+                </a:solidFill>
+                <a:latin typeface="Microsoft YaHei"/>
+              </a:defRPr>
+            </a:pPr>
+            <a:r>
+              <a:t>属性类型 (Attributes)</a:t>
+            </a:r>
+          </a:p>
+        </p:txBody>
+      </p:sp>
+      <p:sp>
+        <p:nvSpPr>
+          <p:cNvPr id="9" name="TextBox 8"/>
+          <p:cNvSpPr txBox="1"/>
+          <p:nvPr/>
+        </p:nvSpPr>
+        <p:spPr>
+          <a:xfrm>
+            <a:off x="4480560" y="1463040"/>
+            <a:ext cx="3291840" cy="4572000"/>
+          </a:xfrm>
+          <a:prstGeom prst="rect">
+            <a:avLst/>
+          </a:prstGeom>
+          <a:noFill/>
+        </p:spPr>
+        <p:txBody>
+          <a:bodyPr wrap="square">
+            <a:spAutoFit/>
+          </a:bodyPr>
+          <a:lstStyle/>
+          <a:p>
+            <a:pPr algn="l">
+              <a:defRPr sz="1000" b="0">
+                <a:solidFill>
+                  <a:srgbClr val="333333"/>
+                </a:solidFill>
+                <a:latin typeface="Menlo"/>
+              </a:defRPr>
+            </a:pPr>
+            <a:r>
+              <a:t>isotropic_material_att</a:t>
+            </a:r>
+            <a:br/>
+            <a:r>
+              <a:t>  各向同性材料 (k, rho, cp)</a:t>
+            </a:r>
+            <a:br/>
+            <a:r>
+              <a:t>orthotropic_material_att</a:t>
+            </a:r>
+            <a:br/>
+            <a:r>
+              <a:t>  正交各向异性 (kx, ky, kz)</a:t>
+            </a:r>
+            <a:br/>
+            <a:r>
+              <a:t>biaxial_material_att</a:t>
+            </a:r>
+            <a:br/>
+            <a:r>
+              <a:t>  双轴材料 (in_plane, normal)</a:t>
+            </a:r>
+            <a:br/>
+            <a:br/>
+            <a:r>
+              <a:t>source_att</a:t>
+            </a:r>
+            <a:br/>
+            <a:r>
+              <a:t>  total / volume / area / fixed</a:t>
+            </a:r>
+            <a:br/>
+            <a:r>
+              <a:t>  / linear / non_linear</a:t>
+            </a:r>
+            <a:br/>
+            <a:br/>
+            <a:r>
+              <a:t>surface_att</a:t>
+            </a:r>
+            <a:br/>
+            <a:r>
+              <a:t>  emissivity, roughness</a:t>
+            </a:r>
+            <a:br/>
+            <a:r>
+              <a:t>radiation_att</a:t>
+            </a:r>
+            <a:br/>
+            <a:r>
+              <a:t>  non_radiating / single /</a:t>
+            </a:r>
+            <a:br/>
+            <a:r>
+              <a:t>  subdivided_radiating</a:t>
+            </a:r>
+            <a:br/>
+            <a:r>
+              <a:t>ambient_att</a:t>
+            </a:r>
+            <a:br/>
+            <a:r>
+              <a:t>  temperature, pressure,</a:t>
+            </a:r>
+            <a:br/>
+            <a:r>
+              <a:t>  velocity, HTC</a:t>
+            </a:r>
+            <a:br/>
+            <a:r>
+              <a:t>thermal_att</a:t>
+            </a:r>
+            <a:br/>
+            <a:r>
+              <a:t>  conduction / convection /</a:t>
+            </a:r>
+            <a:br/>
+            <a:r>
+              <a:t>  fixed_temperature</a:t>
+            </a:r>
+            <a:br/>
+            <a:r>
+              <a:t>fan_att</a:t>
+            </a:r>
+            <a:br/>
+            <a:r>
+              <a:t>  normal / angled / swirl</a:t>
+            </a:r>
+            <a:br/>
+            <a:r>
+              <a:t>  + fan_curve_points</a:t>
+            </a:r>
+          </a:p>
+        </p:txBody>
+      </p:sp>
+      <p:sp>
+        <p:nvSpPr>
+          <p:cNvPr id="10" name="Rectangle 9"/>
+          <p:cNvSpPr/>
+          <p:nvPr/>
+        </p:nvSpPr>
+        <p:spPr>
+          <a:xfrm>
+            <a:off x="8138160" y="1005840"/>
+            <a:ext cx="3657600" cy="3108960"/>
+          </a:xfrm>
+          <a:prstGeom prst="rect">
+            <a:avLst/>
+          </a:prstGeom>
+          <a:solidFill>
+            <a:srgbClr val="F2F2F2"/>
+          </a:solidFill>
+          <a:ln>
+            <a:noFill/>
+          </a:ln>
+        </p:spPr>
+        <p:style>
+          <a:lnRef idx="1">
+            <a:schemeClr val="accent1"/>
+          </a:lnRef>
+          <a:fillRef idx="3">
+            <a:schemeClr val="accent1"/>
+          </a:fillRef>
+          <a:effectRef idx="2">
+            <a:schemeClr val="accent1"/>
+          </a:effectRef>
+          <a:fontRef idx="minor">
+            <a:schemeClr val="lt1"/>
+          </a:fontRef>
+        </p:style>
+        <p:txBody>
+          <a:bodyPr rtlCol="0" anchor="ctr"/>
+          <a:lstStyle/>
+          <a:p>
+            <a:pPr algn="ctr"/>
+          </a:p>
+        </p:txBody>
+      </p:sp>
+      <p:sp>
+        <p:nvSpPr>
+          <p:cNvPr id="11" name="TextBox 10"/>
+          <p:cNvSpPr txBox="1"/>
+          <p:nvPr/>
+        </p:nvSpPr>
+        <p:spPr>
+          <a:xfrm>
+            <a:off x="8321040" y="1097280"/>
+            <a:ext cx="3291840" cy="320040"/>
+          </a:xfrm>
+          <a:prstGeom prst="rect">
+            <a:avLst/>
+          </a:prstGeom>
+          <a:noFill/>
+        </p:spPr>
+        <p:txBody>
+          <a:bodyPr wrap="square">
+            <a:spAutoFit/>
+          </a:bodyPr>
+          <a:lstStyle/>
+          <a:p>
+            <a:pPr algn="l">
+              <a:defRPr sz="1400" b="1">
+                <a:solidFill>
+                  <a:srgbClr val="8E44AD"/>
+                </a:solidFill>
+                <a:latin typeface="Microsoft YaHei"/>
+              </a:defRPr>
+            </a:pPr>
+            <a:r>
+              <a:t>几何体类型</a:t>
+            </a:r>
+          </a:p>
+        </p:txBody>
+      </p:sp>
+      <p:sp>
+        <p:nvSpPr>
+          <p:cNvPr id="12" name="TextBox 11"/>
+          <p:cNvSpPr txBox="1"/>
+          <p:nvPr/>
+        </p:nvSpPr>
+        <p:spPr>
+          <a:xfrm>
+            <a:off x="8321040" y="1463040"/>
+            <a:ext cx="3291840" cy="2560320"/>
+          </a:xfrm>
+          <a:prstGeom prst="rect">
+            <a:avLst/>
+          </a:prstGeom>
+          <a:noFill/>
+        </p:spPr>
+        <p:txBody>
+          <a:bodyPr wrap="square">
+            <a:spAutoFit/>
+          </a:bodyPr>
+          <a:lstStyle/>
+          <a:p>
+            <a:pPr algn="l">
+              <a:defRPr sz="1000" b="0">
+                <a:solidFill>
+                  <a:srgbClr val="333333"/>
+                </a:solidFill>
+                <a:latin typeface="Menlo"/>
+              </a:defRPr>
+            </a:pPr>
+            <a:r>
+              <a:t>cuboid       长方体 (最常用)</a:t>
+            </a:r>
+            <a:br/>
+            <a:r>
+              <a:t>plate        薄板 (PCB 等)</a:t>
+            </a:r>
+            <a:br/>
+            <a:r>
+              <a:t>prism        棱柱体</a:t>
+            </a:r>
+            <a:br/>
+            <a:r>
+              <a:t>assembly     装配体 (嵌套)</a:t>
+            </a:r>
+            <a:br/>
+            <a:r>
+              <a:t>fan          风扇</a:t>
+            </a:r>
+            <a:br/>
+            <a:r>
+              <a:t>vent         通风口</a:t>
+            </a:r>
+            <a:br/>
+            <a:r>
+              <a:t>source       热源几何</a:t>
+            </a:r>
+            <a:br/>
+            <a:r>
+              <a:t>monitor_point 监控点</a:t>
+            </a:r>
+            <a:br/>
+            <a:r>
+              <a:t>sloping_block 斜块</a:t>
+            </a:r>
+            <a:br/>
+            <a:r>
+              <a:t>opening      开口</a:t>
+            </a:r>
+            <a:br/>
+            <a:br/>
+            <a:r>
+              <a:t>每个几何体可引用:</a:t>
+            </a:r>
+            <a:br/>
+            <a:r>
+              <a:t> material / thermal / surface</a:t>
+            </a:r>
+            <a:br/>
+            <a:r>
+              <a:t> radiation / source / fan</a:t>
+            </a:r>
+            <a:br/>
+            <a:r>
+              <a:t> ambient / resistance</a:t>
+            </a:r>
+            <a:br/>
+            <a:r>
+              <a:t> grid_constraint (按面)</a:t>
+            </a:r>
+          </a:p>
+        </p:txBody>
+      </p:sp>
+      <p:sp>
+        <p:nvSpPr>
+          <p:cNvPr id="13" name="Rectangle 12"/>
+          <p:cNvSpPr/>
+          <p:nvPr/>
+        </p:nvSpPr>
+        <p:spPr>
+          <a:xfrm>
+            <a:off x="8138160" y="4297680"/>
+            <a:ext cx="3657600" cy="2011680"/>
+          </a:xfrm>
+          <a:prstGeom prst="rect">
+            <a:avLst/>
+          </a:prstGeom>
+          <a:solidFill>
+            <a:srgbClr val="D6E4F0"/>
+          </a:solidFill>
+          <a:ln>
+            <a:noFill/>
+          </a:ln>
+        </p:spPr>
+        <p:style>
+          <a:lnRef idx="1">
+            <a:schemeClr val="accent1"/>
+          </a:lnRef>
+          <a:fillRef idx="3">
+            <a:schemeClr val="accent1"/>
+          </a:fillRef>
+          <a:effectRef idx="2">
+            <a:schemeClr val="accent1"/>
+          </a:effectRef>
+          <a:fontRef idx="minor">
+            <a:schemeClr val="lt1"/>
+          </a:fontRef>
+        </p:style>
+        <p:txBody>
+          <a:bodyPr rtlCol="0" anchor="ctr"/>
+          <a:lstStyle/>
+          <a:p>
+            <a:pPr algn="ctr"/>
+          </a:p>
+        </p:txBody>
+      </p:sp>
+      <p:sp>
+        <p:nvSpPr>
+          <p:cNvPr id="14" name="TextBox 13"/>
+          <p:cNvSpPr txBox="1"/>
+          <p:nvPr/>
+        </p:nvSpPr>
+        <p:spPr>
+          <a:xfrm>
+            <a:off x="8321040" y="4389120"/>
+            <a:ext cx="3291840" cy="320040"/>
+          </a:xfrm>
+          <a:prstGeom prst="rect">
+            <a:avLst/>
+          </a:prstGeom>
+          <a:noFill/>
+        </p:spPr>
+        <p:txBody>
+          <a:bodyPr wrap="square">
+            <a:spAutoFit/>
+          </a:bodyPr>
+          <a:lstStyle/>
+          <a:p>
+            <a:pPr algn="l">
+              <a:defRPr sz="1400" b="1">
+                <a:solidFill>
+                  <a:srgbClr val="1B3A5C"/>
+                </a:solidFill>
+                <a:latin typeface="Microsoft YaHei"/>
+              </a:defRPr>
+            </a:pPr>
+            <a:r>
+              <a:t>XSD 语法速查</a:t>
+            </a:r>
+          </a:p>
+        </p:txBody>
+      </p:sp>
+      <p:sp>
+        <p:nvSpPr>
+          <p:cNvPr id="15" name="TextBox 14"/>
+          <p:cNvSpPr txBox="1"/>
+          <p:nvPr/>
+        </p:nvSpPr>
+        <p:spPr>
+          <a:xfrm>
+            <a:off x="8321040" y="4754880"/>
+            <a:ext cx="3291840" cy="1371600"/>
+          </a:xfrm>
+          <a:prstGeom prst="rect">
+            <a:avLst/>
+          </a:prstGeom>
+          <a:noFill/>
+        </p:spPr>
+        <p:txBody>
+          <a:bodyPr wrap="square">
+            <a:spAutoFit/>
+          </a:bodyPr>
+          <a:lstStyle/>
+          <a:p>
+            <a:pPr algn="l">
+              <a:defRPr sz="1000" b="0">
+                <a:solidFill>
+                  <a:srgbClr val="333333"/>
+                </a:solidFill>
+                <a:latin typeface="Menlo"/>
+              </a:defRPr>
+            </a:pPr>
+            <a:r>
+              <a:t>minOccurs="0"    可选字段</a:t>
+            </a:r>
+            <a:br/>
+            <a:r>
+              <a:t>minOccurs="1"    必填字段</a:t>
+            </a:r>
+            <a:br/>
+            <a:r>
+              <a:t>enumeration      合法枚举值</a:t>
+            </a:r>
+            <a:br/>
+            <a:r>
+              <a:t>restriction      值约束 (范围)</a:t>
+            </a:r>
+            <a:br/>
+            <a:r>
+              <a:t>&lt;xs:all&gt;         无序, 最多一次</a:t>
+            </a:r>
+            <a:br/>
+            <a:r>
+              <a:t>&lt;xs:sequence&gt;    有序</a:t>
+            </a:r>
+            <a:br/>
+            <a:r>
+              <a:t>&lt;xs:choice&gt;      多选一</a:t>
+            </a:r>
+            <a:br/>
+            <a:r>
+              <a:t>maxOccurs="unbounded"  可重复</a:t>
+            </a:r>
+          </a:p>
+        </p:txBody>
+      </p:sp>
+      <p:sp>
+        <p:nvSpPr>
+          <p:cNvPr id="16" name="TextBox 15"/>
+          <p:cNvSpPr txBox="1"/>
+          <p:nvPr/>
+        </p:nvSpPr>
+        <p:spPr>
+          <a:xfrm>
+            <a:off x="457200" y="6400800"/>
+            <a:ext cx="10972800" cy="365760"/>
+          </a:xfrm>
+          <a:prstGeom prst="rect">
+            <a:avLst/>
+          </a:prstGeom>
+          <a:noFill/>
+        </p:spPr>
+        <p:txBody>
+          <a:bodyPr wrap="square">
+            <a:spAutoFit/>
+          </a:bodyPr>
+          <a:lstStyle/>
+          <a:p>
+            <a:pPr algn="l">
+              <a:defRPr sz="900" b="0">
+                <a:solidFill>
+                  <a:srgbClr val="666666"/>
+                </a:solidFill>
+                <a:latin typeface="Microsoft YaHei"/>
+              </a:defRPr>
+            </a:pPr>
+            <a:r>
+              <a:t>floxml_tools 工作交接  |  2026-06-01</a:t>
+            </a:r>
+          </a:p>
+        </p:txBody>
+      </p:sp>
+    </p:spTree>
+  </p:cSld>
+  <p:clrMapOvr>
+    <a:masterClrMapping/>
+  </p:clrMapOvr>
+</p:sld>
+</file>
+
+<file path=ppt/slides/slide14.xml><?xml version="1.0" encoding="utf-8"?>
+<p:sld xmlns:a="http://schemas.openxmlformats.org/drawingml/2006/main" xmlns:p="http://schemas.openxmlformats.org/presentationml/2006/main" xmlns:r="http://schemas.openxmlformats.org/officeDocument/2006/relationships">
+  <p:cSld>
+    <p:bg>
+      <p:bgPr>
+        <a:solidFill>
+          <a:srgbClr val="FFFFFF"/>
+        </a:solidFill>
+        <a:effectLst/>
+      </p:bgPr>
+    </p:bg>
+    <p:spTree>
+      <p:nvGrpSpPr>
+        <p:cNvPr id="1" name=""/>
+        <p:cNvGrpSpPr/>
+        <p:nvPr/>
+      </p:nvGrpSpPr>
+      <p:grpSpPr/>
+      <p:sp>
+        <p:nvSpPr>
+          <p:cNvPr id="2" name="Rectangle 1"/>
+          <p:cNvSpPr/>
+          <p:nvPr/>
+        </p:nvSpPr>
+        <p:spPr>
+          <a:xfrm>
+            <a:off x="0" y="0"/>
+            <a:ext cx="12191695" cy="73152"/>
+          </a:xfrm>
+          <a:prstGeom prst="rect">
+            <a:avLst/>
+          </a:prstGeom>
+          <a:solidFill>
+            <a:srgbClr val="2E75B6"/>
+          </a:solidFill>
+          <a:ln>
+            <a:noFill/>
+          </a:ln>
+        </p:spPr>
+        <p:style>
+          <a:lnRef idx="1">
+            <a:schemeClr val="accent1"/>
+          </a:lnRef>
+          <a:fillRef idx="3">
+            <a:schemeClr val="accent1"/>
+          </a:fillRef>
+          <a:effectRef idx="2">
+            <a:schemeClr val="accent1"/>
+          </a:effectRef>
+          <a:fontRef idx="minor">
+            <a:schemeClr val="lt1"/>
+          </a:fontRef>
+        </p:style>
+        <p:txBody>
+          <a:bodyPr rtlCol="0" anchor="ctr"/>
+          <a:lstStyle/>
+          <a:p>
+            <a:pPr algn="ctr"/>
+          </a:p>
+        </p:txBody>
+      </p:sp>
+      <p:sp>
+        <p:nvSpPr>
+          <p:cNvPr id="3" name="TextBox 2"/>
+          <p:cNvSpPr txBox="1"/>
+          <p:nvPr/>
+        </p:nvSpPr>
+        <p:spPr>
+          <a:xfrm>
+            <a:off x="548640" y="274320"/>
+            <a:ext cx="10972800" cy="640080"/>
+          </a:xfrm>
+          <a:prstGeom prst="rect">
+            <a:avLst/>
+          </a:prstGeom>
+          <a:noFill/>
+        </p:spPr>
+        <p:txBody>
+          <a:bodyPr wrap="square">
+            <a:spAutoFit/>
+          </a:bodyPr>
+          <a:lstStyle/>
+          <a:p>
+            <a:pPr algn="l">
+              <a:defRPr sz="3200" b="1">
+                <a:solidFill>
+                  <a:srgbClr val="1B3A5C"/>
+                </a:solidFill>
+                <a:latin typeface="Microsoft YaHei"/>
+              </a:defRPr>
+            </a:pPr>
+            <a:r>
+              <a:t>交接总结</a:t>
+            </a:r>
+          </a:p>
+        </p:txBody>
+      </p:sp>
+      <p:sp>
+        <p:nvSpPr>
+          <p:cNvPr id="4" name="Rectangle 3"/>
+          <p:cNvSpPr/>
+          <p:nvPr/>
+        </p:nvSpPr>
+        <p:spPr>
+          <a:xfrm>
+            <a:off x="457200" y="1188720"/>
+            <a:ext cx="11064240" cy="1371600"/>
+          </a:xfrm>
+          <a:prstGeom prst="rect">
+            <a:avLst/>
+          </a:prstGeom>
+          <a:solidFill>
+            <a:srgbClr val="D6E4F0"/>
+          </a:solidFill>
+          <a:ln>
+            <a:noFill/>
+          </a:ln>
+        </p:spPr>
+        <p:style>
+          <a:lnRef idx="1">
+            <a:schemeClr val="accent1"/>
+          </a:lnRef>
+          <a:fillRef idx="3">
+            <a:schemeClr val="accent1"/>
+          </a:fillRef>
+          <a:effectRef idx="2">
+            <a:schemeClr val="accent1"/>
+          </a:effectRef>
+          <a:fontRef idx="minor">
+            <a:schemeClr val="lt1"/>
+          </a:fontRef>
+        </p:style>
+        <p:txBody>
+          <a:bodyPr rtlCol="0" anchor="ctr"/>
+          <a:lstStyle/>
+          <a:p>
+            <a:pPr algn="ctr"/>
+          </a:p>
+        </p:txBody>
+      </p:sp>
+      <p:sp>
+        <p:nvSpPr>
+          <p:cNvPr id="5" name="TextBox 4"/>
+          <p:cNvSpPr txBox="1"/>
+          <p:nvPr/>
+        </p:nvSpPr>
+        <p:spPr>
+          <a:xfrm>
+            <a:off x="640080" y="1280160"/>
+            <a:ext cx="2560320" cy="640080"/>
+          </a:xfrm>
+          <a:prstGeom prst="rect">
+            <a:avLst/>
+          </a:prstGeom>
+          <a:noFill/>
+        </p:spPr>
+        <p:txBody>
+          <a:bodyPr wrap="square">
+            <a:spAutoFit/>
+          </a:bodyPr>
+          <a:lstStyle/>
+          <a:p>
+            <a:pPr algn="ctr">
+              <a:defRPr sz="3600" b="1">
+                <a:solidFill>
+                  <a:srgbClr val="2E75B6"/>
+                </a:solidFill>
+                <a:latin typeface="Microsoft YaHei"/>
+              </a:defRPr>
+            </a:pPr>
+            <a:r>
+              <a:t>4</a:t>
+            </a:r>
+          </a:p>
+        </p:txBody>
+      </p:sp>
+      <p:sp>
+        <p:nvSpPr>
+          <p:cNvPr id="6" name="TextBox 5"/>
+          <p:cNvSpPr txBox="1"/>
+          <p:nvPr/>
+        </p:nvSpPr>
+        <p:spPr>
+          <a:xfrm>
+            <a:off x="640080" y="1828800"/>
+            <a:ext cx="2560320" cy="365760"/>
+          </a:xfrm>
+          <a:prstGeom prst="rect">
+            <a:avLst/>
+          </a:prstGeom>
+          <a:noFill/>
+        </p:spPr>
+        <p:txBody>
+          <a:bodyPr wrap="square">
+            <a:spAutoFit/>
+          </a:bodyPr>
+          <a:lstStyle/>
+          <a:p>
+            <a:pPr algn="ctr">
+              <a:defRPr sz="1300" b="0">
+                <a:solidFill>
+                  <a:srgbClr val="666666"/>
+                </a:solidFill>
+                <a:latin typeface="Microsoft YaHei"/>
+              </a:defRPr>
+            </a:pPr>
+            <a:r>
+              <a:t>核心 Python 模块</a:t>
+            </a:r>
+          </a:p>
+        </p:txBody>
+      </p:sp>
+      <p:sp>
+        <p:nvSpPr>
+          <p:cNvPr id="7" name="TextBox 6"/>
+          <p:cNvSpPr txBox="1"/>
+          <p:nvPr/>
+        </p:nvSpPr>
+        <p:spPr>
+          <a:xfrm>
+            <a:off x="3383280" y="1280160"/>
+            <a:ext cx="2560320" cy="640080"/>
+          </a:xfrm>
+          <a:prstGeom prst="rect">
+            <a:avLst/>
+          </a:prstGeom>
+          <a:noFill/>
+        </p:spPr>
+        <p:txBody>
+          <a:bodyPr wrap="square">
+            <a:spAutoFit/>
+          </a:bodyPr>
+          <a:lstStyle/>
+          <a:p>
+            <a:pPr algn="ctr">
+              <a:defRPr sz="3600" b="1">
+                <a:solidFill>
+                  <a:srgbClr val="2E75B6"/>
+                </a:solidFill>
+                <a:latin typeface="Microsoft YaHei"/>
+              </a:defRPr>
+            </a:pPr>
+            <a:r>
+              <a:t>~5,200</a:t>
+            </a:r>
+          </a:p>
+        </p:txBody>
+      </p:sp>
+      <p:sp>
+        <p:nvSpPr>
+          <p:cNvPr id="8" name="TextBox 7"/>
+          <p:cNvSpPr txBox="1"/>
+          <p:nvPr/>
+        </p:nvSpPr>
+        <p:spPr>
+          <a:xfrm>
+            <a:off x="3383280" y="1828800"/>
+            <a:ext cx="2560320" cy="365760"/>
+          </a:xfrm>
+          <a:prstGeom prst="rect">
+            <a:avLst/>
+          </a:prstGeom>
+          <a:noFill/>
+        </p:spPr>
+        <p:txBody>
+          <a:bodyPr wrap="square">
+            <a:spAutoFit/>
+          </a:bodyPr>
+          <a:lstStyle/>
+          <a:p>
+            <a:pPr algn="ctr">
+              <a:defRPr sz="1300" b="0">
+                <a:solidFill>
+                  <a:srgbClr val="666666"/>
+                </a:solidFill>
+                <a:latin typeface="Microsoft YaHei"/>
+              </a:defRPr>
+            </a:pPr>
+            <a:r>
+              <a:t>行核心代码</a:t>
+            </a:r>
+          </a:p>
+        </p:txBody>
+      </p:sp>
+      <p:sp>
+        <p:nvSpPr>
+          <p:cNvPr id="9" name="TextBox 8"/>
+          <p:cNvSpPr txBox="1"/>
+          <p:nvPr/>
+        </p:nvSpPr>
+        <p:spPr>
+          <a:xfrm>
+            <a:off x="6126480" y="1280160"/>
+            <a:ext cx="2560320" cy="640080"/>
+          </a:xfrm>
+          <a:prstGeom prst="rect">
+            <a:avLst/>
+          </a:prstGeom>
+          <a:noFill/>
+        </p:spPr>
+        <p:txBody>
+          <a:bodyPr wrap="square">
+            <a:spAutoFit/>
+          </a:bodyPr>
+          <a:lstStyle/>
+          <a:p>
+            <a:pPr algn="ctr">
+              <a:defRPr sz="3600" b="1">
+                <a:solidFill>
+                  <a:srgbClr val="2E75B6"/>
+                </a:solidFill>
+                <a:latin typeface="Microsoft YaHei"/>
+              </a:defRPr>
+            </a:pPr>
+            <a:r>
+              <a:t>6+</a:t>
+            </a:r>
+          </a:p>
+        </p:txBody>
+      </p:sp>
+      <p:sp>
+        <p:nvSpPr>
+          <p:cNvPr id="10" name="TextBox 9"/>
+          <p:cNvSpPr txBox="1"/>
+          <p:nvPr/>
+        </p:nvSpPr>
+        <p:spPr>
+          <a:xfrm>
+            <a:off x="6126480" y="1828800"/>
+            <a:ext cx="2560320" cy="365760"/>
+          </a:xfrm>
+          <a:prstGeom prst="rect">
+            <a:avLst/>
+          </a:prstGeom>
+          <a:noFill/>
+        </p:spPr>
+        <p:txBody>
+          <a:bodyPr wrap="square">
+            <a:spAutoFit/>
+          </a:bodyPr>
+          <a:lstStyle/>
+          <a:p>
+            <a:pPr algn="ctr">
+              <a:defRPr sz="1300" b="0">
+                <a:solidFill>
+                  <a:srgbClr val="666666"/>
+                </a:solidFill>
+                <a:latin typeface="Microsoft YaHei"/>
+              </a:defRPr>
+            </a:pPr>
+            <a:r>
+              <a:t>JSON 配置文件</a:t>
+            </a:r>
+          </a:p>
+        </p:txBody>
+      </p:sp>
+      <p:sp>
+        <p:nvSpPr>
+          <p:cNvPr id="11" name="TextBox 10"/>
+          <p:cNvSpPr txBox="1"/>
+          <p:nvPr/>
+        </p:nvSpPr>
+        <p:spPr>
+          <a:xfrm>
+            <a:off x="8869680" y="1280160"/>
+            <a:ext cx="2560320" cy="640080"/>
+          </a:xfrm>
+          <a:prstGeom prst="rect">
+            <a:avLst/>
+          </a:prstGeom>
+          <a:noFill/>
+        </p:spPr>
+        <p:txBody>
+          <a:bodyPr wrap="square">
+            <a:spAutoFit/>
+          </a:bodyPr>
+          <a:lstStyle/>
+          <a:p>
+            <a:pPr algn="ctr">
+              <a:defRPr sz="3600" b="1">
+                <a:solidFill>
+                  <a:srgbClr val="2E75B6"/>
+                </a:solidFill>
+                <a:latin typeface="Microsoft YaHei"/>
+              </a:defRPr>
+            </a:pPr>
+            <a:r>
+              <a:t>7</a:t>
+            </a:r>
+          </a:p>
+        </p:txBody>
+      </p:sp>
+      <p:sp>
+        <p:nvSpPr>
+          <p:cNvPr id="12" name="TextBox 11"/>
+          <p:cNvSpPr txBox="1"/>
+          <p:nvPr/>
+        </p:nvSpPr>
+        <p:spPr>
+          <a:xfrm>
+            <a:off x="8869680" y="1828800"/>
+            <a:ext cx="2560320" cy="365760"/>
+          </a:xfrm>
+          <a:prstGeom prst="rect">
+            <a:avLst/>
+          </a:prstGeom>
+          <a:noFill/>
+        </p:spPr>
+        <p:txBody>
+          <a:bodyPr wrap="square">
+            <a:spAutoFit/>
+          </a:bodyPr>
+          <a:lstStyle/>
+          <a:p>
+            <a:pPr algn="ctr">
+              <a:defRPr sz="1300" b="0">
+                <a:solidFill>
+                  <a:srgbClr val="666666"/>
+                </a:solidFill>
+                <a:latin typeface="Microsoft YaHei"/>
+              </a:defRPr>
+            </a:pPr>
+            <a:r>
+              <a:t>边界条件类型</a:t>
+            </a:r>
+          </a:p>
+        </p:txBody>
+      </p:sp>
+      <p:sp>
+        <p:nvSpPr>
+          <p:cNvPr id="13" name="TextBox 12"/>
+          <p:cNvSpPr txBox="1"/>
+          <p:nvPr/>
+        </p:nvSpPr>
+        <p:spPr>
+          <a:xfrm>
+            <a:off x="548640" y="2926080"/>
+            <a:ext cx="10972800" cy="365760"/>
+          </a:xfrm>
+          <a:prstGeom prst="rect">
+            <a:avLst/>
+          </a:prstGeom>
+          <a:noFill/>
+        </p:spPr>
+        <p:txBody>
+          <a:bodyPr wrap="square">
+            <a:spAutoFit/>
+          </a:bodyPr>
+          <a:lstStyle/>
+          <a:p>
+            <a:pPr algn="l">
+              <a:defRPr sz="2000" b="1">
+                <a:solidFill>
+                  <a:srgbClr val="1B3A5C"/>
+                </a:solidFill>
+                <a:latin typeface="Microsoft YaHei"/>
+              </a:defRPr>
+            </a:pPr>
+            <a:r>
+              <a:t>核心要点</a:t>
+            </a:r>
+          </a:p>
+        </p:txBody>
+      </p:sp>
+      <p:sp>
+        <p:nvSpPr>
+          <p:cNvPr id="14" name="TextBox 13"/>
+          <p:cNvSpPr txBox="1"/>
+          <p:nvPr/>
+        </p:nvSpPr>
+        <p:spPr>
+          <a:xfrm>
+            <a:off x="548640" y="3383280"/>
+            <a:ext cx="10972800" cy="2286000"/>
+          </a:xfrm>
+          <a:prstGeom prst="rect">
+            <a:avLst/>
+          </a:prstGeom>
+          <a:noFill/>
+        </p:spPr>
+        <p:txBody>
+          <a:bodyPr wrap="square">
+            <a:spAutoFit/>
+          </a:bodyPr>
+          <a:lstStyle/>
+          <a:p>
+            <a:pPr>
+              <a:spcAft>
+                <a:spcPts val="600"/>
+              </a:spcAft>
+              <a:defRPr sz="1400">
+                <a:solidFill>
+                  <a:srgbClr val="333333"/>
+                </a:solidFill>
+                <a:latin typeface="Microsoft YaHei"/>
+              </a:defRPr>
+            </a:pPr>
+            <a:r>
+              <a:t>1. 工作流: FloTHERM 导出 ECXML → ecxml_to_floxml_converter 转换 → 三个 JSON 配置修改 FloXML → 导入求解</a:t>
+            </a:r>
+          </a:p>
+          <a:p>
+            <a:pPr>
+              <a:spcAft>
+                <a:spcPts val="600"/>
+              </a:spcAft>
+              <a:defRPr sz="1400">
+                <a:solidFill>
+                  <a:srgbClr val="333333"/>
+                </a:solidFill>
+                <a:latin typeface="Microsoft YaHei"/>
+              </a:defRPr>
+            </a:pPr>
+            <a:r>
+              <a:t>2. 三个配置修改脚本各司其职: solve_settings / volume_regions / boundary_conditions</a:t>
+            </a:r>
+          </a:p>
+          <a:p>
+            <a:pPr>
+              <a:spcAft>
+                <a:spcPts val="600"/>
+              </a:spcAft>
+              <a:defRPr sz="1400">
+                <a:solidFill>
+                  <a:srgbClr val="333333"/>
+                </a:solidFill>
+                <a:latin typeface="Microsoft YaHei"/>
+              </a:defRPr>
+            </a:pPr>
+            <a:r>
+              <a:t>3. JSON 配置驱动: 修改参数只需改 JSON，不需要手动编辑 XML</a:t>
+            </a:r>
+          </a:p>
+          <a:p>
+            <a:pPr>
+              <a:spcAft>
+                <a:spcPts val="600"/>
+              </a:spcAft>
+              <a:defRPr sz="1400">
+                <a:solidFill>
+                  <a:srgbClr val="333333"/>
+                </a:solidFill>
+                <a:latin typeface="Microsoft YaHei"/>
+              </a:defRPr>
+            </a:pPr>
+            <a:r>
+              <a:t>4. 所有模块都有命令行入口，支持 -h 查看帮助</a:t>
+            </a:r>
+          </a:p>
+          <a:p>
+            <a:pPr>
+              <a:spcAft>
+                <a:spcPts val="600"/>
+              </a:spcAft>
+              <a:defRPr sz="1400">
+                <a:solidFill>
+                  <a:srgbClr val="333333"/>
+                </a:solidFill>
+                <a:latin typeface="Microsoft YaHei"/>
+              </a:defRPr>
+            </a:pPr>
+            <a:r>
+              <a:t>5. 每个模块有完整 docstring，包含用法示例和参数说明</a:t>
+            </a:r>
+          </a:p>
+        </p:txBody>
+      </p:sp>
+      <p:sp>
+        <p:nvSpPr>
+          <p:cNvPr id="15" name="Rectangle 14"/>
+          <p:cNvSpPr/>
+          <p:nvPr/>
+        </p:nvSpPr>
+        <p:spPr>
+          <a:xfrm>
+            <a:off x="457200" y="5120640"/>
+            <a:ext cx="11064240" cy="1188720"/>
+          </a:xfrm>
+          <a:prstGeom prst="rect">
+            <a:avLst/>
+          </a:prstGeom>
+          <a:solidFill>
+            <a:srgbClr val="F2F2F2"/>
+          </a:solidFill>
+          <a:ln>
+            <a:noFill/>
+          </a:ln>
+        </p:spPr>
+        <p:style>
+          <a:lnRef idx="1">
+            <a:schemeClr val="accent1"/>
+          </a:lnRef>
+          <a:fillRef idx="3">
+            <a:schemeClr val="accent1"/>
+          </a:fillRef>
+          <a:effectRef idx="2">
+            <a:schemeClr val="accent1"/>
+          </a:effectRef>
+          <a:fontRef idx="minor">
+            <a:schemeClr val="lt1"/>
+          </a:fontRef>
+        </p:style>
+        <p:txBody>
+          <a:bodyPr rtlCol="0" anchor="ctr"/>
+          <a:lstStyle/>
+          <a:p>
+            <a:pPr algn="ctr"/>
+          </a:p>
+        </p:txBody>
+      </p:sp>
+      <p:sp>
+        <p:nvSpPr>
+          <p:cNvPr id="16" name="TextBox 15"/>
+          <p:cNvSpPr txBox="1"/>
+          <p:nvPr/>
+        </p:nvSpPr>
+        <p:spPr>
+          <a:xfrm>
+            <a:off x="640080" y="5212080"/>
+            <a:ext cx="10698480" cy="274320"/>
+          </a:xfrm>
+          <a:prstGeom prst="rect">
+            <a:avLst/>
+          </a:prstGeom>
+          <a:noFill/>
+        </p:spPr>
+        <p:txBody>
+          <a:bodyPr wrap="square">
+            <a:spAutoFit/>
+          </a:bodyPr>
+          <a:lstStyle/>
+          <a:p>
+            <a:pPr algn="l">
+              <a:defRPr sz="1400" b="1">
+                <a:solidFill>
+                  <a:srgbClr val="1B3A5C"/>
+                </a:solidFill>
+                <a:latin typeface="Microsoft YaHei"/>
+              </a:defRPr>
+            </a:pPr>
+            <a:r>
+              <a:t>后续建议</a:t>
+            </a:r>
+          </a:p>
+        </p:txBody>
+      </p:sp>
+      <p:sp>
+        <p:nvSpPr>
+          <p:cNvPr id="17" name="TextBox 16"/>
+          <p:cNvSpPr txBox="1"/>
+          <p:nvPr/>
+        </p:nvSpPr>
+        <p:spPr>
+          <a:xfrm>
+            <a:off x="640080" y="5486400"/>
+            <a:ext cx="10698480" cy="731520"/>
+          </a:xfrm>
+          <a:prstGeom prst="rect">
+            <a:avLst/>
+          </a:prstGeom>
+          <a:noFill/>
+        </p:spPr>
+        <p:txBody>
+          <a:bodyPr wrap="square">
+            <a:spAutoFit/>
+          </a:bodyPr>
+          <a:lstStyle/>
+          <a:p>
+            <a:pPr>
+              <a:spcAft>
+                <a:spcPts val="200"/>
+              </a:spcAft>
+              <a:defRPr sz="1200">
+                <a:solidFill>
+                  <a:srgbClr val="666666"/>
+                </a:solidFill>
+                <a:latin typeface="Microsoft YaHei"/>
+              </a:defRPr>
+            </a:pPr>
+            <a:r>
+              <a:t>• 补充单元测试（目前仅 ecxml_to_floxml_converter 有测试）</a:t>
+            </a:r>
+          </a:p>
+          <a:p>
+            <a:pPr>
+              <a:spcAft>
+                <a:spcPts val="200"/>
+              </a:spcAft>
+              <a:defRPr sz="1200">
+                <a:solidFill>
+                  <a:srgbClr val="666666"/>
+                </a:solidFill>
+                <a:latin typeface="Microsoft YaHei"/>
+              </a:defRPr>
+            </a:pPr>
+            <a:r>
+              <a:t>• 引入 logging 替代 print，便于调试</a:t>
+            </a:r>
+          </a:p>
+        </p:txBody>
+      </p:sp>
+      <p:sp>
+        <p:nvSpPr>
+          <p:cNvPr id="18" name="TextBox 17"/>
+          <p:cNvSpPr txBox="1"/>
+          <p:nvPr/>
+        </p:nvSpPr>
+        <p:spPr>
+          <a:xfrm>
+            <a:off x="457200" y="6400800"/>
+            <a:ext cx="10972800" cy="365760"/>
+          </a:xfrm>
+          <a:prstGeom prst="rect">
+            <a:avLst/>
+          </a:prstGeom>
+          <a:noFill/>
+        </p:spPr>
+        <p:txBody>
+          <a:bodyPr wrap="square">
+            <a:spAutoFit/>
+          </a:bodyPr>
+          <a:lstStyle/>
+          <a:p>
+            <a:pPr algn="l">
+              <a:defRPr sz="900" b="0">
+                <a:solidFill>
+                  <a:srgbClr val="666666"/>
+                </a:solidFill>
+                <a:latin typeface="Microsoft YaHei"/>
+              </a:defRPr>
+            </a:pPr>
+            <a:r>
+              <a:t>floxml_tools 工作交接  |  2026-06-01</a:t>
+            </a:r>
+          </a:p>
+        </p:txBody>
+      </p:sp>
+    </p:spTree>
+  </p:cSld>
+  <p:clrMapOvr>
+    <a:masterClrMapping/>
+  </p:clrMapOvr>
+</p:sld>
+</file>
+
+<file path=ppt/slides/slide15.xml><?xml version="1.0" encoding="utf-8"?>
 <p:sld xmlns:a="http://schemas.openxmlformats.org/drawingml/2006/main" xmlns:p="http://schemas.openxmlformats.org/presentationml/2006/main" xmlns:r="http://schemas.openxmlformats.org/officeDocument/2006/relationships">
   <p:cSld>
     <p:bg>

</xml_diff>

<commit_message>
docs: add CLI solving and batch simulation slides to handover PPT
Generated with [Claude Code](https://claude.ai/code)
via [Happy](https://happy.engineering)

Co-Authored-By: Claude <noreply@anthropic.com>
Co-Authored-By: Happy <yesreply@happy.engineering>
</commit_message>
<xml_diff>
--- a/floxml_tools_工作交接.pptx
+++ b/floxml_tools_工作交接.pptx
@@ -21,6 +21,8 @@
     <p:sldId id="269" r:id="rId20"/>
     <p:sldId id="270" r:id="rId21"/>
     <p:sldId id="271" r:id="rId22"/>
+    <p:sldId id="272" r:id="rId23"/>
+    <p:sldId id="273" r:id="rId24"/>
   </p:sldIdLst>
   <p:sldSz cx="12191695" cy="6858000" type="screen4x3"/>
   <p:notesSz cx="6858000" cy="9144000"/>
@@ -9269,7 +9271,7 @@
             <a:avLst/>
           </a:prstGeom>
           <a:solidFill>
-            <a:srgbClr val="2E75B6"/>
+            <a:srgbClr val="C0392B"/>
           </a:solidFill>
           <a:ln>
             <a:noFill/>
@@ -9328,21 +9330,198 @@
               </a:defRPr>
             </a:pPr>
             <a:r>
-              <a:t>交接总结</a:t>
-            </a:r>
-          </a:p>
-        </p:txBody>
-      </p:sp>
-      <p:sp>
-        <p:nvSpPr>
-          <p:cNvPr id="4" name="Rectangle 3"/>
+              <a:t>命令行求解 &amp; 结果保存</a:t>
+            </a:r>
+          </a:p>
+        </p:txBody>
+      </p:sp>
+      <p:sp>
+        <p:nvSpPr>
+          <p:cNvPr id="4" name="TextBox 3"/>
+          <p:cNvSpPr txBox="1"/>
+          <p:nvPr/>
+        </p:nvSpPr>
+        <p:spPr>
+          <a:xfrm>
+            <a:off x="548640" y="1005840"/>
+            <a:ext cx="10972800" cy="365760"/>
+          </a:xfrm>
+          <a:prstGeom prst="rect">
+            <a:avLst/>
+          </a:prstGeom>
+          <a:noFill/>
+        </p:spPr>
+        <p:txBody>
+          <a:bodyPr wrap="square">
+            <a:spAutoFit/>
+          </a:bodyPr>
+          <a:lstStyle/>
+          <a:p>
+            <a:pPr algn="l">
+              <a:defRPr sz="1400" b="0">
+                <a:solidFill>
+                  <a:srgbClr val="666666"/>
+                </a:solidFill>
+                <a:latin typeface="Microsoft YaHei"/>
+              </a:defRPr>
+            </a:pPr>
+            <a:r>
+              <a:t>修改完 FloXML 后，通过命令行调用 FloTHERM 求解，保存为 .pack 项目和 HTML 求解报告。</a:t>
+            </a:r>
+          </a:p>
+        </p:txBody>
+      </p:sp>
+      <p:sp>
+        <p:nvSpPr>
+          <p:cNvPr id="5" name="Rectangle 4"/>
           <p:cNvSpPr/>
           <p:nvPr/>
         </p:nvSpPr>
         <p:spPr>
           <a:xfrm>
-            <a:off x="457200" y="1188720"/>
-            <a:ext cx="11064240" cy="1371600"/>
+            <a:off x="457200" y="1554480"/>
+            <a:ext cx="5486400" cy="2103120"/>
+          </a:xfrm>
+          <a:prstGeom prst="rect">
+            <a:avLst/>
+          </a:prstGeom>
+          <a:solidFill>
+            <a:srgbClr val="F2F2F2"/>
+          </a:solidFill>
+          <a:ln>
+            <a:noFill/>
+          </a:ln>
+        </p:spPr>
+        <p:style>
+          <a:lnRef idx="1">
+            <a:schemeClr val="accent1"/>
+          </a:lnRef>
+          <a:fillRef idx="3">
+            <a:schemeClr val="accent1"/>
+          </a:fillRef>
+          <a:effectRef idx="2">
+            <a:schemeClr val="accent1"/>
+          </a:effectRef>
+          <a:fontRef idx="minor">
+            <a:schemeClr val="lt1"/>
+          </a:fontRef>
+        </p:style>
+        <p:txBody>
+          <a:bodyPr rtlCol="0" anchor="ctr"/>
+          <a:lstStyle/>
+          <a:p>
+            <a:pPr algn="ctr"/>
+          </a:p>
+        </p:txBody>
+      </p:sp>
+      <p:sp>
+        <p:nvSpPr>
+          <p:cNvPr id="6" name="TextBox 5"/>
+          <p:cNvSpPr txBox="1"/>
+          <p:nvPr/>
+        </p:nvSpPr>
+        <p:spPr>
+          <a:xfrm>
+            <a:off x="640080" y="1645920"/>
+            <a:ext cx="5120640" cy="320040"/>
+          </a:xfrm>
+          <a:prstGeom prst="rect">
+            <a:avLst/>
+          </a:prstGeom>
+          <a:noFill/>
+        </p:spPr>
+        <p:txBody>
+          <a:bodyPr wrap="square">
+            <a:spAutoFit/>
+          </a:bodyPr>
+          <a:lstStyle/>
+          <a:p>
+            <a:pPr algn="l">
+              <a:defRPr sz="1500" b="1">
+                <a:solidFill>
+                  <a:srgbClr val="C0392B"/>
+                </a:solidFill>
+                <a:latin typeface="Microsoft YaHei"/>
+              </a:defRPr>
+            </a:pPr>
+            <a:r>
+              <a:t>单文件求解</a:t>
+            </a:r>
+          </a:p>
+        </p:txBody>
+      </p:sp>
+      <p:sp>
+        <p:nvSpPr>
+          <p:cNvPr id="7" name="TextBox 6"/>
+          <p:cNvSpPr txBox="1"/>
+          <p:nvPr/>
+        </p:nvSpPr>
+        <p:spPr>
+          <a:xfrm>
+            <a:off x="640080" y="2011680"/>
+            <a:ext cx="5120640" cy="1463040"/>
+          </a:xfrm>
+          <a:prstGeom prst="rect">
+            <a:avLst/>
+          </a:prstGeom>
+          <a:noFill/>
+        </p:spPr>
+        <p:txBody>
+          <a:bodyPr wrap="square">
+            <a:spAutoFit/>
+          </a:bodyPr>
+          <a:lstStyle/>
+          <a:p>
+            <a:pPr algn="l">
+              <a:defRPr sz="1100" b="0">
+                <a:solidFill>
+                  <a:srgbClr val="333333"/>
+                </a:solidFill>
+                <a:latin typeface="Menlo"/>
+              </a:defRPr>
+            </a:pPr>
+            <a:r>
+              <a:t># ECXML 直接求解 → 保存 .pack + HTML 报告</a:t>
+            </a:r>
+            <a:br/>
+            <a:r>
+              <a:t>flotherm -b model.ecxml \</a:t>
+            </a:r>
+            <a:br/>
+            <a:r>
+              <a:t>  -z output.pack -r report.html</a:t>
+            </a:r>
+            <a:br/>
+            <a:br/>
+            <a:r>
+              <a:t># FloXML 求解</a:t>
+            </a:r>
+            <a:br/>
+            <a:r>
+              <a:t>flotherm -b project.xml</a:t>
+            </a:r>
+            <a:br/>
+            <a:br/>
+            <a:r>
+              <a:t># FloSCRIPT 脚本求解 (最灵活)</a:t>
+            </a:r>
+            <a:br/>
+            <a:r>
+              <a:t>flotherm -b -f solve_script.xml</a:t>
+            </a:r>
+          </a:p>
+        </p:txBody>
+      </p:sp>
+      <p:sp>
+        <p:nvSpPr>
+          <p:cNvPr id="8" name="Rectangle 7"/>
+          <p:cNvSpPr/>
+          <p:nvPr/>
+        </p:nvSpPr>
+        <p:spPr>
+          <a:xfrm>
+            <a:off x="6217920" y="1554480"/>
+            <a:ext cx="5486400" cy="2103120"/>
           </a:xfrm>
           <a:prstGeom prst="rect">
             <a:avLst/>
@@ -9378,180 +9557,36 @@
       </p:sp>
       <p:sp>
         <p:nvSpPr>
-          <p:cNvPr id="5" name="TextBox 4"/>
-          <p:cNvSpPr txBox="1"/>
-          <p:nvPr/>
-        </p:nvSpPr>
-        <p:spPr>
-          <a:xfrm>
-            <a:off x="640080" y="1280160"/>
-            <a:ext cx="2560320" cy="640080"/>
-          </a:xfrm>
-          <a:prstGeom prst="rect">
-            <a:avLst/>
-          </a:prstGeom>
-          <a:noFill/>
-        </p:spPr>
-        <p:txBody>
-          <a:bodyPr wrap="square">
-            <a:spAutoFit/>
-          </a:bodyPr>
-          <a:lstStyle/>
-          <a:p>
-            <a:pPr algn="ctr">
-              <a:defRPr sz="3600" b="1">
-                <a:solidFill>
-                  <a:srgbClr val="2E75B6"/>
-                </a:solidFill>
-                <a:latin typeface="Microsoft YaHei"/>
-              </a:defRPr>
-            </a:pPr>
-            <a:r>
-              <a:t>4</a:t>
-            </a:r>
-          </a:p>
-        </p:txBody>
-      </p:sp>
-      <p:sp>
-        <p:nvSpPr>
-          <p:cNvPr id="6" name="TextBox 5"/>
-          <p:cNvSpPr txBox="1"/>
-          <p:nvPr/>
-        </p:nvSpPr>
-        <p:spPr>
-          <a:xfrm>
-            <a:off x="640080" y="1828800"/>
-            <a:ext cx="2560320" cy="365760"/>
-          </a:xfrm>
-          <a:prstGeom prst="rect">
-            <a:avLst/>
-          </a:prstGeom>
-          <a:noFill/>
-        </p:spPr>
-        <p:txBody>
-          <a:bodyPr wrap="square">
-            <a:spAutoFit/>
-          </a:bodyPr>
-          <a:lstStyle/>
-          <a:p>
-            <a:pPr algn="ctr">
-              <a:defRPr sz="1300" b="0">
-                <a:solidFill>
-                  <a:srgbClr val="666666"/>
-                </a:solidFill>
-                <a:latin typeface="Microsoft YaHei"/>
-              </a:defRPr>
-            </a:pPr>
-            <a:r>
-              <a:t>核心 Python 模块</a:t>
-            </a:r>
-          </a:p>
-        </p:txBody>
-      </p:sp>
-      <p:sp>
-        <p:nvSpPr>
-          <p:cNvPr id="7" name="TextBox 6"/>
-          <p:cNvSpPr txBox="1"/>
-          <p:nvPr/>
-        </p:nvSpPr>
-        <p:spPr>
-          <a:xfrm>
-            <a:off x="3383280" y="1280160"/>
-            <a:ext cx="2560320" cy="640080"/>
-          </a:xfrm>
-          <a:prstGeom prst="rect">
-            <a:avLst/>
-          </a:prstGeom>
-          <a:noFill/>
-        </p:spPr>
-        <p:txBody>
-          <a:bodyPr wrap="square">
-            <a:spAutoFit/>
-          </a:bodyPr>
-          <a:lstStyle/>
-          <a:p>
-            <a:pPr algn="ctr">
-              <a:defRPr sz="3600" b="1">
-                <a:solidFill>
-                  <a:srgbClr val="2E75B6"/>
-                </a:solidFill>
-                <a:latin typeface="Microsoft YaHei"/>
-              </a:defRPr>
-            </a:pPr>
-            <a:r>
-              <a:t>~5,200</a:t>
-            </a:r>
-          </a:p>
-        </p:txBody>
-      </p:sp>
-      <p:sp>
-        <p:nvSpPr>
-          <p:cNvPr id="8" name="TextBox 7"/>
-          <p:cNvSpPr txBox="1"/>
-          <p:nvPr/>
-        </p:nvSpPr>
-        <p:spPr>
-          <a:xfrm>
-            <a:off x="3383280" y="1828800"/>
-            <a:ext cx="2560320" cy="365760"/>
-          </a:xfrm>
-          <a:prstGeom prst="rect">
-            <a:avLst/>
-          </a:prstGeom>
-          <a:noFill/>
-        </p:spPr>
-        <p:txBody>
-          <a:bodyPr wrap="square">
-            <a:spAutoFit/>
-          </a:bodyPr>
-          <a:lstStyle/>
-          <a:p>
-            <a:pPr algn="ctr">
-              <a:defRPr sz="1300" b="0">
-                <a:solidFill>
-                  <a:srgbClr val="666666"/>
-                </a:solidFill>
-                <a:latin typeface="Microsoft YaHei"/>
-              </a:defRPr>
-            </a:pPr>
-            <a:r>
-              <a:t>行核心代码</a:t>
-            </a:r>
-          </a:p>
-        </p:txBody>
-      </p:sp>
-      <p:sp>
-        <p:nvSpPr>
           <p:cNvPr id="9" name="TextBox 8"/>
           <p:cNvSpPr txBox="1"/>
           <p:nvPr/>
         </p:nvSpPr>
         <p:spPr>
           <a:xfrm>
-            <a:off x="6126480" y="1280160"/>
-            <a:ext cx="2560320" cy="640080"/>
-          </a:xfrm>
-          <a:prstGeom prst="rect">
-            <a:avLst/>
-          </a:prstGeom>
-          <a:noFill/>
-        </p:spPr>
-        <p:txBody>
-          <a:bodyPr wrap="square">
-            <a:spAutoFit/>
-          </a:bodyPr>
-          <a:lstStyle/>
-          <a:p>
-            <a:pPr algn="ctr">
-              <a:defRPr sz="3600" b="1">
-                <a:solidFill>
-                  <a:srgbClr val="2E75B6"/>
-                </a:solidFill>
-                <a:latin typeface="Microsoft YaHei"/>
-              </a:defRPr>
-            </a:pPr>
-            <a:r>
-              <a:t>6+</a:t>
+            <a:off x="6400800" y="1645920"/>
+            <a:ext cx="5120640" cy="320040"/>
+          </a:xfrm>
+          <a:prstGeom prst="rect">
+            <a:avLst/>
+          </a:prstGeom>
+          <a:noFill/>
+        </p:spPr>
+        <p:txBody>
+          <a:bodyPr wrap="square">
+            <a:spAutoFit/>
+          </a:bodyPr>
+          <a:lstStyle/>
+          <a:p>
+            <a:pPr algn="l">
+              <a:defRPr sz="1500" b="1">
+                <a:solidFill>
+                  <a:srgbClr val="1B3A5C"/>
+                </a:solidFill>
+                <a:latin typeface="Microsoft YaHei"/>
+              </a:defRPr>
+            </a:pPr>
+            <a:r>
+              <a:t>关键参数说明</a:t>
             </a:r>
           </a:p>
         </p:txBody>
@@ -9564,152 +9599,8 @@
         </p:nvSpPr>
         <p:spPr>
           <a:xfrm>
-            <a:off x="6126480" y="1828800"/>
-            <a:ext cx="2560320" cy="365760"/>
-          </a:xfrm>
-          <a:prstGeom prst="rect">
-            <a:avLst/>
-          </a:prstGeom>
-          <a:noFill/>
-        </p:spPr>
-        <p:txBody>
-          <a:bodyPr wrap="square">
-            <a:spAutoFit/>
-          </a:bodyPr>
-          <a:lstStyle/>
-          <a:p>
-            <a:pPr algn="ctr">
-              <a:defRPr sz="1300" b="0">
-                <a:solidFill>
-                  <a:srgbClr val="666666"/>
-                </a:solidFill>
-                <a:latin typeface="Microsoft YaHei"/>
-              </a:defRPr>
-            </a:pPr>
-            <a:r>
-              <a:t>JSON 配置文件</a:t>
-            </a:r>
-          </a:p>
-        </p:txBody>
-      </p:sp>
-      <p:sp>
-        <p:nvSpPr>
-          <p:cNvPr id="11" name="TextBox 10"/>
-          <p:cNvSpPr txBox="1"/>
-          <p:nvPr/>
-        </p:nvSpPr>
-        <p:spPr>
-          <a:xfrm>
-            <a:off x="8869680" y="1280160"/>
-            <a:ext cx="2560320" cy="640080"/>
-          </a:xfrm>
-          <a:prstGeom prst="rect">
-            <a:avLst/>
-          </a:prstGeom>
-          <a:noFill/>
-        </p:spPr>
-        <p:txBody>
-          <a:bodyPr wrap="square">
-            <a:spAutoFit/>
-          </a:bodyPr>
-          <a:lstStyle/>
-          <a:p>
-            <a:pPr algn="ctr">
-              <a:defRPr sz="3600" b="1">
-                <a:solidFill>
-                  <a:srgbClr val="2E75B6"/>
-                </a:solidFill>
-                <a:latin typeface="Microsoft YaHei"/>
-              </a:defRPr>
-            </a:pPr>
-            <a:r>
-              <a:t>7</a:t>
-            </a:r>
-          </a:p>
-        </p:txBody>
-      </p:sp>
-      <p:sp>
-        <p:nvSpPr>
-          <p:cNvPr id="12" name="TextBox 11"/>
-          <p:cNvSpPr txBox="1"/>
-          <p:nvPr/>
-        </p:nvSpPr>
-        <p:spPr>
-          <a:xfrm>
-            <a:off x="8869680" y="1828800"/>
-            <a:ext cx="2560320" cy="365760"/>
-          </a:xfrm>
-          <a:prstGeom prst="rect">
-            <a:avLst/>
-          </a:prstGeom>
-          <a:noFill/>
-        </p:spPr>
-        <p:txBody>
-          <a:bodyPr wrap="square">
-            <a:spAutoFit/>
-          </a:bodyPr>
-          <a:lstStyle/>
-          <a:p>
-            <a:pPr algn="ctr">
-              <a:defRPr sz="1300" b="0">
-                <a:solidFill>
-                  <a:srgbClr val="666666"/>
-                </a:solidFill>
-                <a:latin typeface="Microsoft YaHei"/>
-              </a:defRPr>
-            </a:pPr>
-            <a:r>
-              <a:t>边界条件类型</a:t>
-            </a:r>
-          </a:p>
-        </p:txBody>
-      </p:sp>
-      <p:sp>
-        <p:nvSpPr>
-          <p:cNvPr id="13" name="TextBox 12"/>
-          <p:cNvSpPr txBox="1"/>
-          <p:nvPr/>
-        </p:nvSpPr>
-        <p:spPr>
-          <a:xfrm>
-            <a:off x="548640" y="2926080"/>
-            <a:ext cx="10972800" cy="365760"/>
-          </a:xfrm>
-          <a:prstGeom prst="rect">
-            <a:avLst/>
-          </a:prstGeom>
-          <a:noFill/>
-        </p:spPr>
-        <p:txBody>
-          <a:bodyPr wrap="square">
-            <a:spAutoFit/>
-          </a:bodyPr>
-          <a:lstStyle/>
-          <a:p>
-            <a:pPr algn="l">
-              <a:defRPr sz="2000" b="1">
-                <a:solidFill>
-                  <a:srgbClr val="1B3A5C"/>
-                </a:solidFill>
-                <a:latin typeface="Microsoft YaHei"/>
-              </a:defRPr>
-            </a:pPr>
-            <a:r>
-              <a:t>核心要点</a:t>
-            </a:r>
-          </a:p>
-        </p:txBody>
-      </p:sp>
-      <p:sp>
-        <p:nvSpPr>
-          <p:cNvPr id="14" name="TextBox 13"/>
-          <p:cNvSpPr txBox="1"/>
-          <p:nvPr/>
-        </p:nvSpPr>
-        <p:spPr>
-          <a:xfrm>
-            <a:off x="548640" y="3383280"/>
-            <a:ext cx="10972800" cy="2286000"/>
+            <a:off x="6400800" y="2011680"/>
+            <a:ext cx="5120640" cy="1463040"/>
           </a:xfrm>
           <a:prstGeom prst="rect">
             <a:avLst/>
@@ -9724,9 +9615,9 @@
           <a:p>
             <a:pPr>
               <a:spcAft>
-                <a:spcPts val="600"/>
+                <a:spcPts val="400"/>
               </a:spcAft>
-              <a:defRPr sz="1400">
+              <a:defRPr sz="1200">
                 <a:solidFill>
                   <a:srgbClr val="333333"/>
                 </a:solidFill>
@@ -9734,15 +9625,15 @@
               </a:defRPr>
             </a:pPr>
             <a:r>
-              <a:t>1. 工作流: FloTHERM 导出 ECXML → ecxml_to_floxml_converter 转换 → 三个 JSON 配置修改 FloXML → 导入求解</a:t>
+              <a:t>-b              batch mode (无 GUI)</a:t>
             </a:r>
           </a:p>
           <a:p>
             <a:pPr>
               <a:spcAft>
-                <a:spcPts val="600"/>
+                <a:spcPts val="400"/>
               </a:spcAft>
-              <a:defRPr sz="1400">
+              <a:defRPr sz="1200">
                 <a:solidFill>
                   <a:srgbClr val="333333"/>
                 </a:solidFill>
@@ -9750,15 +9641,15 @@
               </a:defRPr>
             </a:pPr>
             <a:r>
-              <a:t>2. 三个配置修改脚本各司其职: solve_settings / volume_regions / boundary_conditions</a:t>
+              <a:t>-f script.xml   执行 FloSCRIPT 脚本</a:t>
             </a:r>
           </a:p>
           <a:p>
             <a:pPr>
               <a:spcAft>
-                <a:spcPts val="600"/>
+                <a:spcPts val="400"/>
               </a:spcAft>
-              <a:defRPr sz="1400">
+              <a:defRPr sz="1200">
                 <a:solidFill>
                   <a:srgbClr val="333333"/>
                 </a:solidFill>
@@ -9766,15 +9657,15 @@
               </a:defRPr>
             </a:pPr>
             <a:r>
-              <a:t>3. JSON 配置驱动: 修改参数只需改 JSON，不需要手动编辑 XML</a:t>
+              <a:t>-z output.pack  保存结果为 .pack 文件</a:t>
             </a:r>
           </a:p>
           <a:p>
             <a:pPr>
               <a:spcAft>
-                <a:spcPts val="600"/>
+                <a:spcPts val="400"/>
               </a:spcAft>
-              <a:defRPr sz="1400">
+              <a:defRPr sz="1200">
                 <a:solidFill>
                   <a:srgbClr val="333333"/>
                 </a:solidFill>
@@ -9782,15 +9673,15 @@
               </a:defRPr>
             </a:pPr>
             <a:r>
-              <a:t>4. 所有模块都有命令行入口，支持 -h 查看帮助</a:t>
+              <a:t>-r report.html  生成 HTML 求解报告</a:t>
             </a:r>
           </a:p>
           <a:p>
             <a:pPr>
               <a:spcAft>
-                <a:spcPts val="600"/>
+                <a:spcPts val="400"/>
               </a:spcAft>
-              <a:defRPr sz="1400">
+              <a:defRPr sz="1200">
                 <a:solidFill>
                   <a:srgbClr val="333333"/>
                 </a:solidFill>
@@ -9798,21 +9689,21 @@
               </a:defRPr>
             </a:pPr>
             <a:r>
-              <a:t>5. 每个模块有完整 docstring，包含用法示例和参数说明</a:t>
-            </a:r>
-          </a:p>
-        </p:txBody>
-      </p:sp>
-      <p:sp>
-        <p:nvSpPr>
-          <p:cNvPr id="15" name="Rectangle 14"/>
+              <a:t>--timeout N     求解超时 (秒)</a:t>
+            </a:r>
+          </a:p>
+        </p:txBody>
+      </p:sp>
+      <p:sp>
+        <p:nvSpPr>
+          <p:cNvPr id="11" name="Rectangle 10"/>
           <p:cNvSpPr/>
           <p:nvPr/>
         </p:nvSpPr>
         <p:spPr>
           <a:xfrm>
-            <a:off x="457200" y="5120640"/>
-            <a:ext cx="11064240" cy="1188720"/>
+            <a:off x="457200" y="3840480"/>
+            <a:ext cx="5486400" cy="2560320"/>
           </a:xfrm>
           <a:prstGeom prst="rect">
             <a:avLst/>
@@ -9848,14 +9739,199 @@
       </p:sp>
       <p:sp>
         <p:nvSpPr>
+          <p:cNvPr id="12" name="TextBox 11"/>
+          <p:cNvSpPr txBox="1"/>
+          <p:nvPr/>
+        </p:nvSpPr>
+        <p:spPr>
+          <a:xfrm>
+            <a:off x="640080" y="3931920"/>
+            <a:ext cx="5120640" cy="320040"/>
+          </a:xfrm>
+          <a:prstGeom prst="rect">
+            <a:avLst/>
+          </a:prstGeom>
+          <a:noFill/>
+        </p:spPr>
+        <p:txBody>
+          <a:bodyPr wrap="square">
+            <a:spAutoFit/>
+          </a:bodyPr>
+          <a:lstStyle/>
+          <a:p>
+            <a:pPr algn="l">
+              <a:defRPr sz="1500" b="1">
+                <a:solidFill>
+                  <a:srgbClr val="2E75B6"/>
+                </a:solidFill>
+                <a:latin typeface="Microsoft YaHei"/>
+              </a:defRPr>
+            </a:pPr>
+            <a:r>
+              <a:t>.pack 文件操作</a:t>
+            </a:r>
+          </a:p>
+        </p:txBody>
+      </p:sp>
+      <p:sp>
+        <p:nvSpPr>
+          <p:cNvPr id="13" name="TextBox 12"/>
+          <p:cNvSpPr txBox="1"/>
+          <p:nvPr/>
+        </p:nvSpPr>
+        <p:spPr>
+          <a:xfrm>
+            <a:off x="640080" y="4297680"/>
+            <a:ext cx="5120640" cy="1828800"/>
+          </a:xfrm>
+          <a:prstGeom prst="rect">
+            <a:avLst/>
+          </a:prstGeom>
+          <a:noFill/>
+        </p:spPr>
+        <p:txBody>
+          <a:bodyPr wrap="square">
+            <a:spAutoFit/>
+          </a:bodyPr>
+          <a:lstStyle/>
+          <a:p>
+            <a:pPr algn="l">
+              <a:defRPr sz="1100" b="0">
+                <a:solidFill>
+                  <a:srgbClr val="333333"/>
+                </a:solidFill>
+                <a:latin typeface="Menlo"/>
+              </a:defRPr>
+            </a:pPr>
+            <a:r>
+              <a:t># 查看 pack 内容</a:t>
+            </a:r>
+            <a:br/>
+            <a:r>
+              <a:t>python pack_editor.py model.pack --list</a:t>
+            </a:r>
+            <a:br/>
+            <a:br/>
+            <a:r>
+              <a:t># 解压 pack 文件</a:t>
+            </a:r>
+            <a:br/>
+            <a:r>
+              <a:t>python pack_editor.py model.pack \</a:t>
+            </a:r>
+            <a:br/>
+            <a:r>
+              <a:t>  --extract ./extracted</a:t>
+            </a:r>
+            <a:br/>
+            <a:br/>
+            <a:r>
+              <a:t># 修改 pack 中的功耗</a:t>
+            </a:r>
+            <a:br/>
+            <a:r>
+              <a:t>python pack_editor.py model.pack \</a:t>
+            </a:r>
+            <a:br/>
+            <a:r>
+              <a:t>  --set-power U1_CPU 15.0 \</a:t>
+            </a:r>
+            <a:br/>
+            <a:r>
+              <a:t>  -o modified.pack</a:t>
+            </a:r>
+          </a:p>
+        </p:txBody>
+      </p:sp>
+      <p:sp>
+        <p:nvSpPr>
+          <p:cNvPr id="14" name="Rectangle 13"/>
+          <p:cNvSpPr/>
+          <p:nvPr/>
+        </p:nvSpPr>
+        <p:spPr>
+          <a:xfrm>
+            <a:off x="6217920" y="3840480"/>
+            <a:ext cx="5486400" cy="2560320"/>
+          </a:xfrm>
+          <a:prstGeom prst="rect">
+            <a:avLst/>
+          </a:prstGeom>
+          <a:solidFill>
+            <a:srgbClr val="F2F2F2"/>
+          </a:solidFill>
+          <a:ln>
+            <a:noFill/>
+          </a:ln>
+        </p:spPr>
+        <p:style>
+          <a:lnRef idx="1">
+            <a:schemeClr val="accent1"/>
+          </a:lnRef>
+          <a:fillRef idx="3">
+            <a:schemeClr val="accent1"/>
+          </a:fillRef>
+          <a:effectRef idx="2">
+            <a:schemeClr val="accent1"/>
+          </a:effectRef>
+          <a:fontRef idx="minor">
+            <a:schemeClr val="lt1"/>
+          </a:fontRef>
+        </p:style>
+        <p:txBody>
+          <a:bodyPr rtlCol="0" anchor="ctr"/>
+          <a:lstStyle/>
+          <a:p>
+            <a:pPr algn="ctr"/>
+          </a:p>
+        </p:txBody>
+      </p:sp>
+      <p:sp>
+        <p:nvSpPr>
+          <p:cNvPr id="15" name="TextBox 14"/>
+          <p:cNvSpPr txBox="1"/>
+          <p:nvPr/>
+        </p:nvSpPr>
+        <p:spPr>
+          <a:xfrm>
+            <a:off x="6400800" y="3931920"/>
+            <a:ext cx="5120640" cy="320040"/>
+          </a:xfrm>
+          <a:prstGeom prst="rect">
+            <a:avLst/>
+          </a:prstGeom>
+          <a:noFill/>
+        </p:spPr>
+        <p:txBody>
+          <a:bodyPr wrap="square">
+            <a:spAutoFit/>
+          </a:bodyPr>
+          <a:lstStyle/>
+          <a:p>
+            <a:pPr algn="l">
+              <a:defRPr sz="1500" b="1">
+                <a:solidFill>
+                  <a:srgbClr val="ED7D31"/>
+                </a:solidFill>
+                <a:latin typeface="Microsoft YaHei"/>
+              </a:defRPr>
+            </a:pPr>
+            <a:r>
+              <a:t>Python 求解工具</a:t>
+            </a:r>
+          </a:p>
+        </p:txBody>
+      </p:sp>
+      <p:sp>
+        <p:nvSpPr>
           <p:cNvPr id="16" name="TextBox 15"/>
           <p:cNvSpPr txBox="1"/>
           <p:nvPr/>
         </p:nvSpPr>
         <p:spPr>
           <a:xfrm>
-            <a:off x="640080" y="5212080"/>
-            <a:ext cx="10698480" cy="274320"/>
+            <a:off x="6400800" y="4297680"/>
+            <a:ext cx="5120640" cy="1828800"/>
           </a:xfrm>
           <a:prstGeom prst="rect">
             <a:avLst/>
@@ -9869,15 +9945,49 @@
           <a:lstStyle/>
           <a:p>
             <a:pPr algn="l">
-              <a:defRPr sz="1400" b="1">
-                <a:solidFill>
-                  <a:srgbClr val="1B3A5C"/>
-                </a:solidFill>
-                <a:latin typeface="Microsoft YaHei"/>
-              </a:defRPr>
-            </a:pPr>
-            <a:r>
-              <a:t>后续建议</a:t>
+              <a:defRPr sz="1100" b="0">
+                <a:solidFill>
+                  <a:srgbClr val="333333"/>
+                </a:solidFill>
+                <a:latin typeface="Menlo"/>
+              </a:defRPr>
+            </a:pPr>
+            <a:r>
+              <a:t># 批量求解文件夹</a:t>
+            </a:r>
+            <a:br/>
+            <a:r>
+              <a:t>python batch_ecxml_solver.py \</a:t>
+            </a:r>
+            <a:br/>
+            <a:r>
+              <a:t>  ./input_folder -o ./output</a:t>
+            </a:r>
+            <a:br/>
+            <a:br/>
+            <a:r>
+              <a:t># FloSCRIPT 运行器 (支持功耗修改)</a:t>
+            </a:r>
+            <a:br/>
+            <a:r>
+              <a:t>python floscript_runner.py model.floxml \</a:t>
+            </a:r>
+            <a:br/>
+            <a:r>
+              <a:t>  -o ./output --power U1_CPU=15.0</a:t>
+            </a:r>
+            <a:br/>
+            <a:br/>
+            <a:r>
+              <a:t># 批量求解器 (支持多种格式)</a:t>
+            </a:r>
+            <a:br/>
+            <a:r>
+              <a:t>python flotherm_batch_solver.py model.xml \</a:t>
+            </a:r>
+            <a:br/>
+            <a:r>
+              <a:t>  -o ./output --mode auto</a:t>
             </a:r>
           </a:p>
         </p:txBody>
@@ -9885,61 +9995,6 @@
       <p:sp>
         <p:nvSpPr>
           <p:cNvPr id="17" name="TextBox 16"/>
-          <p:cNvSpPr txBox="1"/>
-          <p:nvPr/>
-        </p:nvSpPr>
-        <p:spPr>
-          <a:xfrm>
-            <a:off x="640080" y="5486400"/>
-            <a:ext cx="10698480" cy="731520"/>
-          </a:xfrm>
-          <a:prstGeom prst="rect">
-            <a:avLst/>
-          </a:prstGeom>
-          <a:noFill/>
-        </p:spPr>
-        <p:txBody>
-          <a:bodyPr wrap="square">
-            <a:spAutoFit/>
-          </a:bodyPr>
-          <a:lstStyle/>
-          <a:p>
-            <a:pPr>
-              <a:spcAft>
-                <a:spcPts val="200"/>
-              </a:spcAft>
-              <a:defRPr sz="1200">
-                <a:solidFill>
-                  <a:srgbClr val="666666"/>
-                </a:solidFill>
-                <a:latin typeface="Microsoft YaHei"/>
-              </a:defRPr>
-            </a:pPr>
-            <a:r>
-              <a:t>• 补充单元测试（目前仅 ecxml_to_floxml_converter 有测试）</a:t>
-            </a:r>
-          </a:p>
-          <a:p>
-            <a:pPr>
-              <a:spcAft>
-                <a:spcPts val="200"/>
-              </a:spcAft>
-              <a:defRPr sz="1200">
-                <a:solidFill>
-                  <a:srgbClr val="666666"/>
-                </a:solidFill>
-                <a:latin typeface="Microsoft YaHei"/>
-              </a:defRPr>
-            </a:pPr>
-            <a:r>
-              <a:t>• 引入 logging 替代 print，便于调试</a:t>
-            </a:r>
-          </a:p>
-        </p:txBody>
-      </p:sp>
-      <p:sp>
-        <p:nvSpPr>
-          <p:cNvPr id="18" name="TextBox 17"/>
           <p:cNvSpPr txBox="1"/>
           <p:nvPr/>
         </p:nvSpPr>
@@ -9982,6 +10037,1547 @@
 </file>
 
 <file path=ppt/slides/slide16.xml><?xml version="1.0" encoding="utf-8"?>
+<p:sld xmlns:a="http://schemas.openxmlformats.org/drawingml/2006/main" xmlns:p="http://schemas.openxmlformats.org/presentationml/2006/main" xmlns:r="http://schemas.openxmlformats.org/officeDocument/2006/relationships">
+  <p:cSld>
+    <p:bg>
+      <p:bgPr>
+        <a:solidFill>
+          <a:srgbClr val="FFFFFF"/>
+        </a:solidFill>
+        <a:effectLst/>
+      </p:bgPr>
+    </p:bg>
+    <p:spTree>
+      <p:nvGrpSpPr>
+        <p:cNvPr id="1" name=""/>
+        <p:cNvGrpSpPr/>
+        <p:nvPr/>
+      </p:nvGrpSpPr>
+      <p:grpSpPr/>
+      <p:sp>
+        <p:nvSpPr>
+          <p:cNvPr id="2" name="Rectangle 1"/>
+          <p:cNvSpPr/>
+          <p:nvPr/>
+        </p:nvSpPr>
+        <p:spPr>
+          <a:xfrm>
+            <a:off x="0" y="0"/>
+            <a:ext cx="12191695" cy="73152"/>
+          </a:xfrm>
+          <a:prstGeom prst="rect">
+            <a:avLst/>
+          </a:prstGeom>
+          <a:solidFill>
+            <a:srgbClr val="8E44AD"/>
+          </a:solidFill>
+          <a:ln>
+            <a:noFill/>
+          </a:ln>
+        </p:spPr>
+        <p:style>
+          <a:lnRef idx="1">
+            <a:schemeClr val="accent1"/>
+          </a:lnRef>
+          <a:fillRef idx="3">
+            <a:schemeClr val="accent1"/>
+          </a:fillRef>
+          <a:effectRef idx="2">
+            <a:schemeClr val="accent1"/>
+          </a:effectRef>
+          <a:fontRef idx="minor">
+            <a:schemeClr val="lt1"/>
+          </a:fontRef>
+        </p:style>
+        <p:txBody>
+          <a:bodyPr rtlCol="0" anchor="ctr"/>
+          <a:lstStyle/>
+          <a:p>
+            <a:pPr algn="ctr"/>
+          </a:p>
+        </p:txBody>
+      </p:sp>
+      <p:sp>
+        <p:nvSpPr>
+          <p:cNvPr id="3" name="TextBox 2"/>
+          <p:cNvSpPr txBox="1"/>
+          <p:nvPr/>
+        </p:nvSpPr>
+        <p:spPr>
+          <a:xfrm>
+            <a:off x="548640" y="274320"/>
+            <a:ext cx="10972800" cy="640080"/>
+          </a:xfrm>
+          <a:prstGeom prst="rect">
+            <a:avLst/>
+          </a:prstGeom>
+          <a:noFill/>
+        </p:spPr>
+        <p:txBody>
+          <a:bodyPr wrap="square">
+            <a:spAutoFit/>
+          </a:bodyPr>
+          <a:lstStyle/>
+          <a:p>
+            <a:pPr algn="l">
+              <a:defRPr sz="3200" b="1">
+                <a:solidFill>
+                  <a:srgbClr val="1B3A5C"/>
+                </a:solidFill>
+                <a:latin typeface="Microsoft YaHei"/>
+              </a:defRPr>
+            </a:pPr>
+            <a:r>
+              <a:t>批量求解 — batch_simulation</a:t>
+            </a:r>
+          </a:p>
+        </p:txBody>
+      </p:sp>
+      <p:sp>
+        <p:nvSpPr>
+          <p:cNvPr id="4" name="TextBox 3"/>
+          <p:cNvSpPr txBox="1"/>
+          <p:nvPr/>
+        </p:nvSpPr>
+        <p:spPr>
+          <a:xfrm>
+            <a:off x="548640" y="1005840"/>
+            <a:ext cx="10972800" cy="365760"/>
+          </a:xfrm>
+          <a:prstGeom prst="rect">
+            <a:avLst/>
+          </a:prstGeom>
+          <a:noFill/>
+        </p:spPr>
+        <p:txBody>
+          <a:bodyPr wrap="square">
+            <a:spAutoFit/>
+          </a:bodyPr>
+          <a:lstStyle/>
+          <a:p>
+            <a:pPr algn="l">
+              <a:defRPr sz="1400" b="0">
+                <a:solidFill>
+                  <a:srgbClr val="666666"/>
+                </a:solidFill>
+                <a:latin typeface="Microsoft YaHei"/>
+              </a:defRPr>
+            </a:pPr>
+            <a:r>
+              <a:t>batch_simulation/ 目录提供完整的批量仿真工具，通过 FloSCRIPT 宏自动加载、修改参数、求解、保存结果。</a:t>
+            </a:r>
+          </a:p>
+        </p:txBody>
+      </p:sp>
+      <p:sp>
+        <p:nvSpPr>
+          <p:cNvPr id="5" name="Rectangle 4"/>
+          <p:cNvSpPr/>
+          <p:nvPr/>
+        </p:nvSpPr>
+        <p:spPr>
+          <a:xfrm>
+            <a:off x="457200" y="1554480"/>
+            <a:ext cx="5486400" cy="2286000"/>
+          </a:xfrm>
+          <a:prstGeom prst="rect">
+            <a:avLst/>
+          </a:prstGeom>
+          <a:solidFill>
+            <a:srgbClr val="F2F2F2"/>
+          </a:solidFill>
+          <a:ln>
+            <a:noFill/>
+          </a:ln>
+        </p:spPr>
+        <p:style>
+          <a:lnRef idx="1">
+            <a:schemeClr val="accent1"/>
+          </a:lnRef>
+          <a:fillRef idx="3">
+            <a:schemeClr val="accent1"/>
+          </a:fillRef>
+          <a:effectRef idx="2">
+            <a:schemeClr val="accent1"/>
+          </a:effectRef>
+          <a:fontRef idx="minor">
+            <a:schemeClr val="lt1"/>
+          </a:fontRef>
+        </p:style>
+        <p:txBody>
+          <a:bodyPr rtlCol="0" anchor="ctr"/>
+          <a:lstStyle/>
+          <a:p>
+            <a:pPr algn="ctr"/>
+          </a:p>
+        </p:txBody>
+      </p:sp>
+      <p:sp>
+        <p:nvSpPr>
+          <p:cNvPr id="6" name="TextBox 5"/>
+          <p:cNvSpPr txBox="1"/>
+          <p:nvPr/>
+        </p:nvSpPr>
+        <p:spPr>
+          <a:xfrm>
+            <a:off x="640080" y="1645920"/>
+            <a:ext cx="5120640" cy="320040"/>
+          </a:xfrm>
+          <a:prstGeom prst="rect">
+            <a:avLst/>
+          </a:prstGeom>
+          <a:noFill/>
+        </p:spPr>
+        <p:txBody>
+          <a:bodyPr wrap="square">
+            <a:spAutoFit/>
+          </a:bodyPr>
+          <a:lstStyle/>
+          <a:p>
+            <a:pPr algn="l">
+              <a:defRPr sz="1500" b="1">
+                <a:solidFill>
+                  <a:srgbClr val="1B3A5C"/>
+                </a:solidFill>
+                <a:latin typeface="Microsoft YaHei"/>
+              </a:defRPr>
+            </a:pPr>
+            <a:r>
+              <a:t>批量求解流程</a:t>
+            </a:r>
+          </a:p>
+        </p:txBody>
+      </p:sp>
+      <p:sp>
+        <p:nvSpPr>
+          <p:cNvPr id="7" name="TextBox 6"/>
+          <p:cNvSpPr txBox="1"/>
+          <p:nvPr/>
+        </p:nvSpPr>
+        <p:spPr>
+          <a:xfrm>
+            <a:off x="640080" y="2011680"/>
+            <a:ext cx="5120640" cy="1645920"/>
+          </a:xfrm>
+          <a:prstGeom prst="rect">
+            <a:avLst/>
+          </a:prstGeom>
+          <a:noFill/>
+        </p:spPr>
+        <p:txBody>
+          <a:bodyPr wrap="square">
+            <a:spAutoFit/>
+          </a:bodyPr>
+          <a:lstStyle/>
+          <a:p>
+            <a:pPr algn="l">
+              <a:defRPr sz="1200" b="0">
+                <a:solidFill>
+                  <a:srgbClr val="333333"/>
+                </a:solidFill>
+                <a:latin typeface="Microsoft YaHei"/>
+              </a:defRPr>
+            </a:pPr>
+            <a:r>
+              <a:t>1. 准备 JSON 配置 (input_pack + modifications)</a:t>
+            </a:r>
+            <a:br/>
+            <a:r>
+              <a:t>2. batch_sim.py 生成 FloSCRIPT XML 脚本</a:t>
+            </a:r>
+            <a:br/>
+            <a:r>
+              <a:t>3. FlothermExecutor 调用 flotherm.exe 执行</a:t>
+            </a:r>
+            <a:br/>
+            <a:r>
+              <a:t>4. 每次求解: load → modify → solve → save_as .pack</a:t>
+            </a:r>
+            <a:br/>
+            <a:r>
+              <a:t>5. extract 命令提取结果到 JSON / CSV</a:t>
+            </a:r>
+          </a:p>
+        </p:txBody>
+      </p:sp>
+      <p:sp>
+        <p:nvSpPr>
+          <p:cNvPr id="8" name="Rectangle 7"/>
+          <p:cNvSpPr/>
+          <p:nvPr/>
+        </p:nvSpPr>
+        <p:spPr>
+          <a:xfrm>
+            <a:off x="6217920" y="1554480"/>
+            <a:ext cx="5486400" cy="2286000"/>
+          </a:xfrm>
+          <a:prstGeom prst="rect">
+            <a:avLst/>
+          </a:prstGeom>
+          <a:solidFill>
+            <a:srgbClr val="F2F2F2"/>
+          </a:solidFill>
+          <a:ln>
+            <a:noFill/>
+          </a:ln>
+        </p:spPr>
+        <p:style>
+          <a:lnRef idx="1">
+            <a:schemeClr val="accent1"/>
+          </a:lnRef>
+          <a:fillRef idx="3">
+            <a:schemeClr val="accent1"/>
+          </a:fillRef>
+          <a:effectRef idx="2">
+            <a:schemeClr val="accent1"/>
+          </a:effectRef>
+          <a:fontRef idx="minor">
+            <a:schemeClr val="lt1"/>
+          </a:fontRef>
+        </p:style>
+        <p:txBody>
+          <a:bodyPr rtlCol="0" anchor="ctr"/>
+          <a:lstStyle/>
+          <a:p>
+            <a:pPr algn="ctr"/>
+          </a:p>
+        </p:txBody>
+      </p:sp>
+      <p:sp>
+        <p:nvSpPr>
+          <p:cNvPr id="9" name="TextBox 8"/>
+          <p:cNvSpPr txBox="1"/>
+          <p:nvPr/>
+        </p:nvSpPr>
+        <p:spPr>
+          <a:xfrm>
+            <a:off x="6400800" y="1645920"/>
+            <a:ext cx="5120640" cy="320040"/>
+          </a:xfrm>
+          <a:prstGeom prst="rect">
+            <a:avLst/>
+          </a:prstGeom>
+          <a:noFill/>
+        </p:spPr>
+        <p:txBody>
+          <a:bodyPr wrap="square">
+            <a:spAutoFit/>
+          </a:bodyPr>
+          <a:lstStyle/>
+          <a:p>
+            <a:pPr algn="l">
+              <a:defRPr sz="1500" b="1">
+                <a:solidFill>
+                  <a:srgbClr val="1B3A5C"/>
+                </a:solidFill>
+                <a:latin typeface="Microsoft YaHei"/>
+              </a:defRPr>
+            </a:pPr>
+            <a:r>
+              <a:t>四个子命令</a:t>
+            </a:r>
+          </a:p>
+        </p:txBody>
+      </p:sp>
+      <p:sp>
+        <p:nvSpPr>
+          <p:cNvPr id="10" name="TextBox 9"/>
+          <p:cNvSpPr txBox="1"/>
+          <p:nvPr/>
+        </p:nvSpPr>
+        <p:spPr>
+          <a:xfrm>
+            <a:off x="6400800" y="2011680"/>
+            <a:ext cx="5120640" cy="1645920"/>
+          </a:xfrm>
+          <a:prstGeom prst="rect">
+            <a:avLst/>
+          </a:prstGeom>
+          <a:noFill/>
+        </p:spPr>
+        <p:txBody>
+          <a:bodyPr wrap="square">
+            <a:spAutoFit/>
+          </a:bodyPr>
+          <a:lstStyle/>
+          <a:p>
+            <a:pPr algn="l">
+              <a:defRPr sz="1000" b="0">
+                <a:solidFill>
+                  <a:srgbClr val="333333"/>
+                </a:solidFill>
+                <a:latin typeface="Menlo"/>
+              </a:defRPr>
+            </a:pPr>
+            <a:r>
+              <a:t># 生成 FloSCRIPT 脚本</a:t>
+            </a:r>
+            <a:br/>
+            <a:r>
+              <a:t>python batch_simulation/batch_sim.py \</a:t>
+            </a:r>
+            <a:br/>
+            <a:r>
+              <a:t>  generate config.json -o ./scripts</a:t>
+            </a:r>
+            <a:br/>
+            <a:br/>
+            <a:r>
+              <a:t># 生成 + 执行</a:t>
+            </a:r>
+            <a:br/>
+            <a:r>
+              <a:t>python batch_simulation/batch_sim.py \</a:t>
+            </a:r>
+            <a:br/>
+            <a:r>
+              <a:t>  run config.json --timeout 7200</a:t>
+            </a:r>
+            <a:br/>
+            <a:br/>
+            <a:r>
+              <a:t># 提取求解结果</a:t>
+            </a:r>
+            <a:br/>
+            <a:r>
+              <a:t>python batch_simulation/batch_sim.py \</a:t>
+            </a:r>
+            <a:br/>
+            <a:r>
+              <a:t>  extract solved.pack -o results.json</a:t>
+            </a:r>
+            <a:br/>
+            <a:br/>
+            <a:r>
+              <a:t># 创建空白 FloXML 项目</a:t>
+            </a:r>
+            <a:br/>
+            <a:r>
+              <a:t>python batch_simulation/batch_sim.py \</a:t>
+            </a:r>
+            <a:br/>
+            <a:r>
+              <a:t>  create-floxml -n MyProject -o project.xml</a:t>
+            </a:r>
+          </a:p>
+        </p:txBody>
+      </p:sp>
+      <p:sp>
+        <p:nvSpPr>
+          <p:cNvPr id="11" name="Rectangle 10"/>
+          <p:cNvSpPr/>
+          <p:nvPr/>
+        </p:nvSpPr>
+        <p:spPr>
+          <a:xfrm>
+            <a:off x="457200" y="4023360"/>
+            <a:ext cx="5486400" cy="2560320"/>
+          </a:xfrm>
+          <a:prstGeom prst="rect">
+            <a:avLst/>
+          </a:prstGeom>
+          <a:solidFill>
+            <a:srgbClr val="F2F2F2"/>
+          </a:solidFill>
+          <a:ln>
+            <a:noFill/>
+          </a:ln>
+        </p:spPr>
+        <p:style>
+          <a:lnRef idx="1">
+            <a:schemeClr val="accent1"/>
+          </a:lnRef>
+          <a:fillRef idx="3">
+            <a:schemeClr val="accent1"/>
+          </a:fillRef>
+          <a:effectRef idx="2">
+            <a:schemeClr val="accent1"/>
+          </a:effectRef>
+          <a:fontRef idx="minor">
+            <a:schemeClr val="lt1"/>
+          </a:fontRef>
+        </p:style>
+        <p:txBody>
+          <a:bodyPr rtlCol="0" anchor="ctr"/>
+          <a:lstStyle/>
+          <a:p>
+            <a:pPr algn="ctr"/>
+          </a:p>
+        </p:txBody>
+      </p:sp>
+      <p:sp>
+        <p:nvSpPr>
+          <p:cNvPr id="12" name="TextBox 11"/>
+          <p:cNvSpPr txBox="1"/>
+          <p:nvPr/>
+        </p:nvSpPr>
+        <p:spPr>
+          <a:xfrm>
+            <a:off x="640080" y="4114800"/>
+            <a:ext cx="5120640" cy="320040"/>
+          </a:xfrm>
+          <a:prstGeom prst="rect">
+            <a:avLst/>
+          </a:prstGeom>
+          <a:noFill/>
+        </p:spPr>
+        <p:txBody>
+          <a:bodyPr wrap="square">
+            <a:spAutoFit/>
+          </a:bodyPr>
+          <a:lstStyle/>
+          <a:p>
+            <a:pPr algn="l">
+              <a:defRPr sz="1300" b="1">
+                <a:solidFill>
+                  <a:srgbClr val="70AD47"/>
+                </a:solidFill>
+                <a:latin typeface="Microsoft YaHei"/>
+              </a:defRPr>
+            </a:pPr>
+            <a:r>
+              <a:t>example_config.json — 单次修改求解</a:t>
+            </a:r>
+          </a:p>
+        </p:txBody>
+      </p:sp>
+      <p:sp>
+        <p:nvSpPr>
+          <p:cNvPr id="13" name="TextBox 12"/>
+          <p:cNvSpPr txBox="1"/>
+          <p:nvPr/>
+        </p:nvSpPr>
+        <p:spPr>
+          <a:xfrm>
+            <a:off x="640080" y="4480560"/>
+            <a:ext cx="5120640" cy="1828800"/>
+          </a:xfrm>
+          <a:prstGeom prst="rect">
+            <a:avLst/>
+          </a:prstGeom>
+          <a:noFill/>
+        </p:spPr>
+        <p:txBody>
+          <a:bodyPr wrap="square">
+            <a:spAutoFit/>
+          </a:bodyPr>
+          <a:lstStyle/>
+          <a:p>
+            <a:pPr algn="l">
+              <a:defRPr sz="1000" b="0">
+                <a:solidFill>
+                  <a:srgbClr val="333333"/>
+                </a:solidFill>
+                <a:latin typeface="Menlo"/>
+              </a:defRPr>
+            </a:pPr>
+            <a:r>
+              <a:t>{</a:t>
+            </a:r>
+            <a:br/>
+            <a:r>
+              <a:t>  "input_pack": "model.pack",</a:t>
+            </a:r>
+            <a:br/>
+            <a:r>
+              <a:t>  "output_pack": "output.pack",</a:t>
+            </a:r>
+            <a:br/>
+            <a:r>
+              <a:t>  "modifications": [</a:t>
+            </a:r>
+            <a:br/>
+            <a:r>
+              <a:t>    {"type": "power", "component": "U1_CPU",</a:t>
+            </a:r>
+            <a:br/>
+            <a:r>
+              <a:t>     "value": 15.0},</a:t>
+            </a:r>
+            <a:br/>
+            <a:r>
+              <a:t>    {"type": "solver", "max_iterations": 500}</a:t>
+            </a:r>
+            <a:br/>
+            <a:r>
+              <a:t>  ],</a:t>
+            </a:r>
+            <a:br/>
+            <a:r>
+              <a:t>  "solve": true</a:t>
+            </a:r>
+            <a:br/>
+            <a:r>
+              <a:t>}</a:t>
+            </a:r>
+          </a:p>
+        </p:txBody>
+      </p:sp>
+      <p:sp>
+        <p:nvSpPr>
+          <p:cNvPr id="14" name="Rectangle 13"/>
+          <p:cNvSpPr/>
+          <p:nvPr/>
+        </p:nvSpPr>
+        <p:spPr>
+          <a:xfrm>
+            <a:off x="6217920" y="4023360"/>
+            <a:ext cx="5486400" cy="2560320"/>
+          </a:xfrm>
+          <a:prstGeom prst="rect">
+            <a:avLst/>
+          </a:prstGeom>
+          <a:solidFill>
+            <a:srgbClr val="D6E4F0"/>
+          </a:solidFill>
+          <a:ln>
+            <a:noFill/>
+          </a:ln>
+        </p:spPr>
+        <p:style>
+          <a:lnRef idx="1">
+            <a:schemeClr val="accent1"/>
+          </a:lnRef>
+          <a:fillRef idx="3">
+            <a:schemeClr val="accent1"/>
+          </a:fillRef>
+          <a:effectRef idx="2">
+            <a:schemeClr val="accent1"/>
+          </a:effectRef>
+          <a:fontRef idx="minor">
+            <a:schemeClr val="lt1"/>
+          </a:fontRef>
+        </p:style>
+        <p:txBody>
+          <a:bodyPr rtlCol="0" anchor="ctr"/>
+          <a:lstStyle/>
+          <a:p>
+            <a:pPr algn="ctr"/>
+          </a:p>
+        </p:txBody>
+      </p:sp>
+      <p:sp>
+        <p:nvSpPr>
+          <p:cNvPr id="15" name="TextBox 14"/>
+          <p:cNvSpPr txBox="1"/>
+          <p:nvPr/>
+        </p:nvSpPr>
+        <p:spPr>
+          <a:xfrm>
+            <a:off x="6400800" y="4114800"/>
+            <a:ext cx="5120640" cy="320040"/>
+          </a:xfrm>
+          <a:prstGeom prst="rect">
+            <a:avLst/>
+          </a:prstGeom>
+          <a:noFill/>
+        </p:spPr>
+        <p:txBody>
+          <a:bodyPr wrap="square">
+            <a:spAutoFit/>
+          </a:bodyPr>
+          <a:lstStyle/>
+          <a:p>
+            <a:pPr algn="l">
+              <a:defRPr sz="1300" b="1">
+                <a:solidFill>
+                  <a:srgbClr val="ED7D31"/>
+                </a:solidFill>
+                <a:latin typeface="Microsoft YaHei"/>
+              </a:defRPr>
+            </a:pPr>
+            <a:r>
+              <a:t>example_param_sweep.json — 参数扫描</a:t>
+            </a:r>
+          </a:p>
+        </p:txBody>
+      </p:sp>
+      <p:sp>
+        <p:nvSpPr>
+          <p:cNvPr id="16" name="TextBox 15"/>
+          <p:cNvSpPr txBox="1"/>
+          <p:nvPr/>
+        </p:nvSpPr>
+        <p:spPr>
+          <a:xfrm>
+            <a:off x="6400800" y="4480560"/>
+            <a:ext cx="5120640" cy="1828800"/>
+          </a:xfrm>
+          <a:prstGeom prst="rect">
+            <a:avLst/>
+          </a:prstGeom>
+          <a:noFill/>
+        </p:spPr>
+        <p:txBody>
+          <a:bodyPr wrap="square">
+            <a:spAutoFit/>
+          </a:bodyPr>
+          <a:lstStyle/>
+          <a:p>
+            <a:pPr algn="l">
+              <a:defRPr sz="1000" b="0">
+                <a:solidFill>
+                  <a:srgbClr val="333333"/>
+                </a:solidFill>
+                <a:latin typeface="Menlo"/>
+              </a:defRPr>
+            </a:pPr>
+            <a:r>
+              <a:t>{</a:t>
+            </a:r>
+            <a:br/>
+            <a:r>
+              <a:t>  "input_pack": "model.pack",</a:t>
+            </a:r>
+            <a:br/>
+            <a:r>
+              <a:t>  "output_pack": "output_{value}.pack",</a:t>
+            </a:r>
+            <a:br/>
+            <a:r>
+              <a:t>  "parameter_sweep": {</a:t>
+            </a:r>
+            <a:br/>
+            <a:r>
+              <a:t>    "component": "U1_CPU",</a:t>
+            </a:r>
+            <a:br/>
+            <a:r>
+              <a:t>    "parameter": "power",</a:t>
+            </a:r>
+            <a:br/>
+            <a:r>
+              <a:t>    "values": [5.0, 10.0, 15.0, 20.0]</a:t>
+            </a:r>
+            <a:br/>
+            <a:r>
+              <a:t>  },</a:t>
+            </a:r>
+            <a:br/>
+            <a:r>
+              <a:t>  "solve": true</a:t>
+            </a:r>
+            <a:br/>
+            <a:r>
+              <a:t>}</a:t>
+            </a:r>
+            <a:br/>
+            <a:r>
+              <a:t># 自动生成 4 个脚本:</a:t>
+            </a:r>
+            <a:br/>
+            <a:r>
+              <a:t># output_5.0.pack / output_10.0.pack / ...</a:t>
+            </a:r>
+          </a:p>
+        </p:txBody>
+      </p:sp>
+      <p:sp>
+        <p:nvSpPr>
+          <p:cNvPr id="17" name="TextBox 16"/>
+          <p:cNvSpPr txBox="1"/>
+          <p:nvPr/>
+        </p:nvSpPr>
+        <p:spPr>
+          <a:xfrm>
+            <a:off x="457200" y="6400800"/>
+            <a:ext cx="10972800" cy="365760"/>
+          </a:xfrm>
+          <a:prstGeom prst="rect">
+            <a:avLst/>
+          </a:prstGeom>
+          <a:noFill/>
+        </p:spPr>
+        <p:txBody>
+          <a:bodyPr wrap="square">
+            <a:spAutoFit/>
+          </a:bodyPr>
+          <a:lstStyle/>
+          <a:p>
+            <a:pPr algn="l">
+              <a:defRPr sz="900" b="0">
+                <a:solidFill>
+                  <a:srgbClr val="666666"/>
+                </a:solidFill>
+                <a:latin typeface="Microsoft YaHei"/>
+              </a:defRPr>
+            </a:pPr>
+            <a:r>
+              <a:t>floxml_tools 工作交接  |  2026-06-01</a:t>
+            </a:r>
+          </a:p>
+        </p:txBody>
+      </p:sp>
+    </p:spTree>
+  </p:cSld>
+  <p:clrMapOvr>
+    <a:masterClrMapping/>
+  </p:clrMapOvr>
+</p:sld>
+</file>
+
+<file path=ppt/slides/slide17.xml><?xml version="1.0" encoding="utf-8"?>
+<p:sld xmlns:a="http://schemas.openxmlformats.org/drawingml/2006/main" xmlns:p="http://schemas.openxmlformats.org/presentationml/2006/main" xmlns:r="http://schemas.openxmlformats.org/officeDocument/2006/relationships">
+  <p:cSld>
+    <p:bg>
+      <p:bgPr>
+        <a:solidFill>
+          <a:srgbClr val="FFFFFF"/>
+        </a:solidFill>
+        <a:effectLst/>
+      </p:bgPr>
+    </p:bg>
+    <p:spTree>
+      <p:nvGrpSpPr>
+        <p:cNvPr id="1" name=""/>
+        <p:cNvGrpSpPr/>
+        <p:nvPr/>
+      </p:nvGrpSpPr>
+      <p:grpSpPr/>
+      <p:sp>
+        <p:nvSpPr>
+          <p:cNvPr id="2" name="Rectangle 1"/>
+          <p:cNvSpPr/>
+          <p:nvPr/>
+        </p:nvSpPr>
+        <p:spPr>
+          <a:xfrm>
+            <a:off x="0" y="0"/>
+            <a:ext cx="12191695" cy="73152"/>
+          </a:xfrm>
+          <a:prstGeom prst="rect">
+            <a:avLst/>
+          </a:prstGeom>
+          <a:solidFill>
+            <a:srgbClr val="2E75B6"/>
+          </a:solidFill>
+          <a:ln>
+            <a:noFill/>
+          </a:ln>
+        </p:spPr>
+        <p:style>
+          <a:lnRef idx="1">
+            <a:schemeClr val="accent1"/>
+          </a:lnRef>
+          <a:fillRef idx="3">
+            <a:schemeClr val="accent1"/>
+          </a:fillRef>
+          <a:effectRef idx="2">
+            <a:schemeClr val="accent1"/>
+          </a:effectRef>
+          <a:fontRef idx="minor">
+            <a:schemeClr val="lt1"/>
+          </a:fontRef>
+        </p:style>
+        <p:txBody>
+          <a:bodyPr rtlCol="0" anchor="ctr"/>
+          <a:lstStyle/>
+          <a:p>
+            <a:pPr algn="ctr"/>
+          </a:p>
+        </p:txBody>
+      </p:sp>
+      <p:sp>
+        <p:nvSpPr>
+          <p:cNvPr id="3" name="TextBox 2"/>
+          <p:cNvSpPr txBox="1"/>
+          <p:nvPr/>
+        </p:nvSpPr>
+        <p:spPr>
+          <a:xfrm>
+            <a:off x="548640" y="274320"/>
+            <a:ext cx="10972800" cy="640080"/>
+          </a:xfrm>
+          <a:prstGeom prst="rect">
+            <a:avLst/>
+          </a:prstGeom>
+          <a:noFill/>
+        </p:spPr>
+        <p:txBody>
+          <a:bodyPr wrap="square">
+            <a:spAutoFit/>
+          </a:bodyPr>
+          <a:lstStyle/>
+          <a:p>
+            <a:pPr algn="l">
+              <a:defRPr sz="3200" b="1">
+                <a:solidFill>
+                  <a:srgbClr val="1B3A5C"/>
+                </a:solidFill>
+                <a:latin typeface="Microsoft YaHei"/>
+              </a:defRPr>
+            </a:pPr>
+            <a:r>
+              <a:t>交接总结</a:t>
+            </a:r>
+          </a:p>
+        </p:txBody>
+      </p:sp>
+      <p:sp>
+        <p:nvSpPr>
+          <p:cNvPr id="4" name="Rectangle 3"/>
+          <p:cNvSpPr/>
+          <p:nvPr/>
+        </p:nvSpPr>
+        <p:spPr>
+          <a:xfrm>
+            <a:off x="457200" y="1188720"/>
+            <a:ext cx="11064240" cy="1371600"/>
+          </a:xfrm>
+          <a:prstGeom prst="rect">
+            <a:avLst/>
+          </a:prstGeom>
+          <a:solidFill>
+            <a:srgbClr val="D6E4F0"/>
+          </a:solidFill>
+          <a:ln>
+            <a:noFill/>
+          </a:ln>
+        </p:spPr>
+        <p:style>
+          <a:lnRef idx="1">
+            <a:schemeClr val="accent1"/>
+          </a:lnRef>
+          <a:fillRef idx="3">
+            <a:schemeClr val="accent1"/>
+          </a:fillRef>
+          <a:effectRef idx="2">
+            <a:schemeClr val="accent1"/>
+          </a:effectRef>
+          <a:fontRef idx="minor">
+            <a:schemeClr val="lt1"/>
+          </a:fontRef>
+        </p:style>
+        <p:txBody>
+          <a:bodyPr rtlCol="0" anchor="ctr"/>
+          <a:lstStyle/>
+          <a:p>
+            <a:pPr algn="ctr"/>
+          </a:p>
+        </p:txBody>
+      </p:sp>
+      <p:sp>
+        <p:nvSpPr>
+          <p:cNvPr id="5" name="TextBox 4"/>
+          <p:cNvSpPr txBox="1"/>
+          <p:nvPr/>
+        </p:nvSpPr>
+        <p:spPr>
+          <a:xfrm>
+            <a:off x="640080" y="1280160"/>
+            <a:ext cx="2560320" cy="640080"/>
+          </a:xfrm>
+          <a:prstGeom prst="rect">
+            <a:avLst/>
+          </a:prstGeom>
+          <a:noFill/>
+        </p:spPr>
+        <p:txBody>
+          <a:bodyPr wrap="square">
+            <a:spAutoFit/>
+          </a:bodyPr>
+          <a:lstStyle/>
+          <a:p>
+            <a:pPr algn="ctr">
+              <a:defRPr sz="3600" b="1">
+                <a:solidFill>
+                  <a:srgbClr val="2E75B6"/>
+                </a:solidFill>
+                <a:latin typeface="Microsoft YaHei"/>
+              </a:defRPr>
+            </a:pPr>
+            <a:r>
+              <a:t>4</a:t>
+            </a:r>
+          </a:p>
+        </p:txBody>
+      </p:sp>
+      <p:sp>
+        <p:nvSpPr>
+          <p:cNvPr id="6" name="TextBox 5"/>
+          <p:cNvSpPr txBox="1"/>
+          <p:nvPr/>
+        </p:nvSpPr>
+        <p:spPr>
+          <a:xfrm>
+            <a:off x="640080" y="1828800"/>
+            <a:ext cx="2560320" cy="365760"/>
+          </a:xfrm>
+          <a:prstGeom prst="rect">
+            <a:avLst/>
+          </a:prstGeom>
+          <a:noFill/>
+        </p:spPr>
+        <p:txBody>
+          <a:bodyPr wrap="square">
+            <a:spAutoFit/>
+          </a:bodyPr>
+          <a:lstStyle/>
+          <a:p>
+            <a:pPr algn="ctr">
+              <a:defRPr sz="1300" b="0">
+                <a:solidFill>
+                  <a:srgbClr val="666666"/>
+                </a:solidFill>
+                <a:latin typeface="Microsoft YaHei"/>
+              </a:defRPr>
+            </a:pPr>
+            <a:r>
+              <a:t>核心 Python 模块</a:t>
+            </a:r>
+          </a:p>
+        </p:txBody>
+      </p:sp>
+      <p:sp>
+        <p:nvSpPr>
+          <p:cNvPr id="7" name="TextBox 6"/>
+          <p:cNvSpPr txBox="1"/>
+          <p:nvPr/>
+        </p:nvSpPr>
+        <p:spPr>
+          <a:xfrm>
+            <a:off x="3383280" y="1280160"/>
+            <a:ext cx="2560320" cy="640080"/>
+          </a:xfrm>
+          <a:prstGeom prst="rect">
+            <a:avLst/>
+          </a:prstGeom>
+          <a:noFill/>
+        </p:spPr>
+        <p:txBody>
+          <a:bodyPr wrap="square">
+            <a:spAutoFit/>
+          </a:bodyPr>
+          <a:lstStyle/>
+          <a:p>
+            <a:pPr algn="ctr">
+              <a:defRPr sz="3600" b="1">
+                <a:solidFill>
+                  <a:srgbClr val="2E75B6"/>
+                </a:solidFill>
+                <a:latin typeface="Microsoft YaHei"/>
+              </a:defRPr>
+            </a:pPr>
+            <a:r>
+              <a:t>~5,200</a:t>
+            </a:r>
+          </a:p>
+        </p:txBody>
+      </p:sp>
+      <p:sp>
+        <p:nvSpPr>
+          <p:cNvPr id="8" name="TextBox 7"/>
+          <p:cNvSpPr txBox="1"/>
+          <p:nvPr/>
+        </p:nvSpPr>
+        <p:spPr>
+          <a:xfrm>
+            <a:off x="3383280" y="1828800"/>
+            <a:ext cx="2560320" cy="365760"/>
+          </a:xfrm>
+          <a:prstGeom prst="rect">
+            <a:avLst/>
+          </a:prstGeom>
+          <a:noFill/>
+        </p:spPr>
+        <p:txBody>
+          <a:bodyPr wrap="square">
+            <a:spAutoFit/>
+          </a:bodyPr>
+          <a:lstStyle/>
+          <a:p>
+            <a:pPr algn="ctr">
+              <a:defRPr sz="1300" b="0">
+                <a:solidFill>
+                  <a:srgbClr val="666666"/>
+                </a:solidFill>
+                <a:latin typeface="Microsoft YaHei"/>
+              </a:defRPr>
+            </a:pPr>
+            <a:r>
+              <a:t>行核心代码</a:t>
+            </a:r>
+          </a:p>
+        </p:txBody>
+      </p:sp>
+      <p:sp>
+        <p:nvSpPr>
+          <p:cNvPr id="9" name="TextBox 8"/>
+          <p:cNvSpPr txBox="1"/>
+          <p:nvPr/>
+        </p:nvSpPr>
+        <p:spPr>
+          <a:xfrm>
+            <a:off x="6126480" y="1280160"/>
+            <a:ext cx="2560320" cy="640080"/>
+          </a:xfrm>
+          <a:prstGeom prst="rect">
+            <a:avLst/>
+          </a:prstGeom>
+          <a:noFill/>
+        </p:spPr>
+        <p:txBody>
+          <a:bodyPr wrap="square">
+            <a:spAutoFit/>
+          </a:bodyPr>
+          <a:lstStyle/>
+          <a:p>
+            <a:pPr algn="ctr">
+              <a:defRPr sz="3600" b="1">
+                <a:solidFill>
+                  <a:srgbClr val="2E75B6"/>
+                </a:solidFill>
+                <a:latin typeface="Microsoft YaHei"/>
+              </a:defRPr>
+            </a:pPr>
+            <a:r>
+              <a:t>6+</a:t>
+            </a:r>
+          </a:p>
+        </p:txBody>
+      </p:sp>
+      <p:sp>
+        <p:nvSpPr>
+          <p:cNvPr id="10" name="TextBox 9"/>
+          <p:cNvSpPr txBox="1"/>
+          <p:nvPr/>
+        </p:nvSpPr>
+        <p:spPr>
+          <a:xfrm>
+            <a:off x="6126480" y="1828800"/>
+            <a:ext cx="2560320" cy="365760"/>
+          </a:xfrm>
+          <a:prstGeom prst="rect">
+            <a:avLst/>
+          </a:prstGeom>
+          <a:noFill/>
+        </p:spPr>
+        <p:txBody>
+          <a:bodyPr wrap="square">
+            <a:spAutoFit/>
+          </a:bodyPr>
+          <a:lstStyle/>
+          <a:p>
+            <a:pPr algn="ctr">
+              <a:defRPr sz="1300" b="0">
+                <a:solidFill>
+                  <a:srgbClr val="666666"/>
+                </a:solidFill>
+                <a:latin typeface="Microsoft YaHei"/>
+              </a:defRPr>
+            </a:pPr>
+            <a:r>
+              <a:t>JSON 配置文件</a:t>
+            </a:r>
+          </a:p>
+        </p:txBody>
+      </p:sp>
+      <p:sp>
+        <p:nvSpPr>
+          <p:cNvPr id="11" name="TextBox 10"/>
+          <p:cNvSpPr txBox="1"/>
+          <p:nvPr/>
+        </p:nvSpPr>
+        <p:spPr>
+          <a:xfrm>
+            <a:off x="8869680" y="1280160"/>
+            <a:ext cx="2560320" cy="640080"/>
+          </a:xfrm>
+          <a:prstGeom prst="rect">
+            <a:avLst/>
+          </a:prstGeom>
+          <a:noFill/>
+        </p:spPr>
+        <p:txBody>
+          <a:bodyPr wrap="square">
+            <a:spAutoFit/>
+          </a:bodyPr>
+          <a:lstStyle/>
+          <a:p>
+            <a:pPr algn="ctr">
+              <a:defRPr sz="3600" b="1">
+                <a:solidFill>
+                  <a:srgbClr val="2E75B6"/>
+                </a:solidFill>
+                <a:latin typeface="Microsoft YaHei"/>
+              </a:defRPr>
+            </a:pPr>
+            <a:r>
+              <a:t>7</a:t>
+            </a:r>
+          </a:p>
+        </p:txBody>
+      </p:sp>
+      <p:sp>
+        <p:nvSpPr>
+          <p:cNvPr id="12" name="TextBox 11"/>
+          <p:cNvSpPr txBox="1"/>
+          <p:nvPr/>
+        </p:nvSpPr>
+        <p:spPr>
+          <a:xfrm>
+            <a:off x="8869680" y="1828800"/>
+            <a:ext cx="2560320" cy="365760"/>
+          </a:xfrm>
+          <a:prstGeom prst="rect">
+            <a:avLst/>
+          </a:prstGeom>
+          <a:noFill/>
+        </p:spPr>
+        <p:txBody>
+          <a:bodyPr wrap="square">
+            <a:spAutoFit/>
+          </a:bodyPr>
+          <a:lstStyle/>
+          <a:p>
+            <a:pPr algn="ctr">
+              <a:defRPr sz="1300" b="0">
+                <a:solidFill>
+                  <a:srgbClr val="666666"/>
+                </a:solidFill>
+                <a:latin typeface="Microsoft YaHei"/>
+              </a:defRPr>
+            </a:pPr>
+            <a:r>
+              <a:t>边界条件类型</a:t>
+            </a:r>
+          </a:p>
+        </p:txBody>
+      </p:sp>
+      <p:sp>
+        <p:nvSpPr>
+          <p:cNvPr id="13" name="TextBox 12"/>
+          <p:cNvSpPr txBox="1"/>
+          <p:nvPr/>
+        </p:nvSpPr>
+        <p:spPr>
+          <a:xfrm>
+            <a:off x="548640" y="2926080"/>
+            <a:ext cx="10972800" cy="365760"/>
+          </a:xfrm>
+          <a:prstGeom prst="rect">
+            <a:avLst/>
+          </a:prstGeom>
+          <a:noFill/>
+        </p:spPr>
+        <p:txBody>
+          <a:bodyPr wrap="square">
+            <a:spAutoFit/>
+          </a:bodyPr>
+          <a:lstStyle/>
+          <a:p>
+            <a:pPr algn="l">
+              <a:defRPr sz="2000" b="1">
+                <a:solidFill>
+                  <a:srgbClr val="1B3A5C"/>
+                </a:solidFill>
+                <a:latin typeface="Microsoft YaHei"/>
+              </a:defRPr>
+            </a:pPr>
+            <a:r>
+              <a:t>核心要点</a:t>
+            </a:r>
+          </a:p>
+        </p:txBody>
+      </p:sp>
+      <p:sp>
+        <p:nvSpPr>
+          <p:cNvPr id="14" name="TextBox 13"/>
+          <p:cNvSpPr txBox="1"/>
+          <p:nvPr/>
+        </p:nvSpPr>
+        <p:spPr>
+          <a:xfrm>
+            <a:off x="548640" y="3383280"/>
+            <a:ext cx="10972800" cy="2286000"/>
+          </a:xfrm>
+          <a:prstGeom prst="rect">
+            <a:avLst/>
+          </a:prstGeom>
+          <a:noFill/>
+        </p:spPr>
+        <p:txBody>
+          <a:bodyPr wrap="square">
+            <a:spAutoFit/>
+          </a:bodyPr>
+          <a:lstStyle/>
+          <a:p>
+            <a:pPr>
+              <a:spcAft>
+                <a:spcPts val="600"/>
+              </a:spcAft>
+              <a:defRPr sz="1400">
+                <a:solidFill>
+                  <a:srgbClr val="333333"/>
+                </a:solidFill>
+                <a:latin typeface="Microsoft YaHei"/>
+              </a:defRPr>
+            </a:pPr>
+            <a:r>
+              <a:t>1. 工作流: 导出 ECXML → 转换 FloXML → JSON 配置修改 → 命令行求解 → 保存 .pack + HTML 报告</a:t>
+            </a:r>
+          </a:p>
+          <a:p>
+            <a:pPr>
+              <a:spcAft>
+                <a:spcPts val="600"/>
+              </a:spcAft>
+              <a:defRPr sz="1400">
+                <a:solidFill>
+                  <a:srgbClr val="333333"/>
+                </a:solidFill>
+                <a:latin typeface="Microsoft YaHei"/>
+              </a:defRPr>
+            </a:pPr>
+            <a:r>
+              <a:t>2. 三个配置修改脚本: solve_settings / volume_regions / boundary_conditions</a:t>
+            </a:r>
+          </a:p>
+          <a:p>
+            <a:pPr>
+              <a:spcAft>
+                <a:spcPts val="600"/>
+              </a:spcAft>
+              <a:defRPr sz="1400">
+                <a:solidFill>
+                  <a:srgbClr val="333333"/>
+                </a:solidFill>
+                <a:latin typeface="Microsoft YaHei"/>
+              </a:defRPr>
+            </a:pPr>
+            <a:r>
+              <a:t>3. pipeline 可一键组合三个修改步骤</a:t>
+            </a:r>
+          </a:p>
+          <a:p>
+            <a:pPr>
+              <a:spcAft>
+                <a:spcPts val="600"/>
+              </a:spcAft>
+              <a:defRPr sz="1400">
+                <a:solidFill>
+                  <a:srgbClr val="333333"/>
+                </a:solidFill>
+                <a:latin typeface="Microsoft YaHei"/>
+              </a:defRPr>
+            </a:pPr>
+            <a:r>
+              <a:t>4. 命令行求解: flotherm -b model.ecxml -z output.pack -r report.html</a:t>
+            </a:r>
+          </a:p>
+          <a:p>
+            <a:pPr>
+              <a:spcAft>
+                <a:spcPts val="600"/>
+              </a:spcAft>
+              <a:defRPr sz="1400">
+                <a:solidFill>
+                  <a:srgbClr val="333333"/>
+                </a:solidFill>
+                <a:latin typeface="Microsoft YaHei"/>
+              </a:defRPr>
+            </a:pPr>
+            <a:r>
+              <a:t>5. 批量求解: batch_simulation/ 支持 JSON 配置驱动的参数扫描</a:t>
+            </a:r>
+          </a:p>
+          <a:p>
+            <a:pPr>
+              <a:spcAft>
+                <a:spcPts val="600"/>
+              </a:spcAft>
+              <a:defRPr sz="1400">
+                <a:solidFill>
+                  <a:srgbClr val="333333"/>
+                </a:solidFill>
+                <a:latin typeface="Microsoft YaHei"/>
+              </a:defRPr>
+            </a:pPr>
+            <a:r>
+              <a:t>6. 所有模块都有命令行入口，支持 -h 查看帮助</a:t>
+            </a:r>
+          </a:p>
+        </p:txBody>
+      </p:sp>
+      <p:sp>
+        <p:nvSpPr>
+          <p:cNvPr id="15" name="Rectangle 14"/>
+          <p:cNvSpPr/>
+          <p:nvPr/>
+        </p:nvSpPr>
+        <p:spPr>
+          <a:xfrm>
+            <a:off x="457200" y="5120640"/>
+            <a:ext cx="11064240" cy="1188720"/>
+          </a:xfrm>
+          <a:prstGeom prst="rect">
+            <a:avLst/>
+          </a:prstGeom>
+          <a:solidFill>
+            <a:srgbClr val="F2F2F2"/>
+          </a:solidFill>
+          <a:ln>
+            <a:noFill/>
+          </a:ln>
+        </p:spPr>
+        <p:style>
+          <a:lnRef idx="1">
+            <a:schemeClr val="accent1"/>
+          </a:lnRef>
+          <a:fillRef idx="3">
+            <a:schemeClr val="accent1"/>
+          </a:fillRef>
+          <a:effectRef idx="2">
+            <a:schemeClr val="accent1"/>
+          </a:effectRef>
+          <a:fontRef idx="minor">
+            <a:schemeClr val="lt1"/>
+          </a:fontRef>
+        </p:style>
+        <p:txBody>
+          <a:bodyPr rtlCol="0" anchor="ctr"/>
+          <a:lstStyle/>
+          <a:p>
+            <a:pPr algn="ctr"/>
+          </a:p>
+        </p:txBody>
+      </p:sp>
+      <p:sp>
+        <p:nvSpPr>
+          <p:cNvPr id="16" name="TextBox 15"/>
+          <p:cNvSpPr txBox="1"/>
+          <p:nvPr/>
+        </p:nvSpPr>
+        <p:spPr>
+          <a:xfrm>
+            <a:off x="640080" y="5212080"/>
+            <a:ext cx="10698480" cy="274320"/>
+          </a:xfrm>
+          <a:prstGeom prst="rect">
+            <a:avLst/>
+          </a:prstGeom>
+          <a:noFill/>
+        </p:spPr>
+        <p:txBody>
+          <a:bodyPr wrap="square">
+            <a:spAutoFit/>
+          </a:bodyPr>
+          <a:lstStyle/>
+          <a:p>
+            <a:pPr algn="l">
+              <a:defRPr sz="1400" b="1">
+                <a:solidFill>
+                  <a:srgbClr val="1B3A5C"/>
+                </a:solidFill>
+                <a:latin typeface="Microsoft YaHei"/>
+              </a:defRPr>
+            </a:pPr>
+            <a:r>
+              <a:t>后续建议</a:t>
+            </a:r>
+          </a:p>
+        </p:txBody>
+      </p:sp>
+      <p:sp>
+        <p:nvSpPr>
+          <p:cNvPr id="17" name="TextBox 16"/>
+          <p:cNvSpPr txBox="1"/>
+          <p:nvPr/>
+        </p:nvSpPr>
+        <p:spPr>
+          <a:xfrm>
+            <a:off x="640080" y="5486400"/>
+            <a:ext cx="10698480" cy="731520"/>
+          </a:xfrm>
+          <a:prstGeom prst="rect">
+            <a:avLst/>
+          </a:prstGeom>
+          <a:noFill/>
+        </p:spPr>
+        <p:txBody>
+          <a:bodyPr wrap="square">
+            <a:spAutoFit/>
+          </a:bodyPr>
+          <a:lstStyle/>
+          <a:p>
+            <a:pPr>
+              <a:spcAft>
+                <a:spcPts val="200"/>
+              </a:spcAft>
+              <a:defRPr sz="1200">
+                <a:solidFill>
+                  <a:srgbClr val="666666"/>
+                </a:solidFill>
+                <a:latin typeface="Microsoft YaHei"/>
+              </a:defRPr>
+            </a:pPr>
+            <a:r>
+              <a:t>• 补充单元测试（目前仅 ecxml_to_floxml_converter 有测试）</a:t>
+            </a:r>
+          </a:p>
+          <a:p>
+            <a:pPr>
+              <a:spcAft>
+                <a:spcPts val="200"/>
+              </a:spcAft>
+              <a:defRPr sz="1200">
+                <a:solidFill>
+                  <a:srgbClr val="666666"/>
+                </a:solidFill>
+                <a:latin typeface="Microsoft YaHei"/>
+              </a:defRPr>
+            </a:pPr>
+            <a:r>
+              <a:t>• 引入 logging 替代 print，便于调试</a:t>
+            </a:r>
+          </a:p>
+        </p:txBody>
+      </p:sp>
+      <p:sp>
+        <p:nvSpPr>
+          <p:cNvPr id="18" name="TextBox 17"/>
+          <p:cNvSpPr txBox="1"/>
+          <p:nvPr/>
+        </p:nvSpPr>
+        <p:spPr>
+          <a:xfrm>
+            <a:off x="457200" y="6400800"/>
+            <a:ext cx="10972800" cy="365760"/>
+          </a:xfrm>
+          <a:prstGeom prst="rect">
+            <a:avLst/>
+          </a:prstGeom>
+          <a:noFill/>
+        </p:spPr>
+        <p:txBody>
+          <a:bodyPr wrap="square">
+            <a:spAutoFit/>
+          </a:bodyPr>
+          <a:lstStyle/>
+          <a:p>
+            <a:pPr algn="l">
+              <a:defRPr sz="900" b="0">
+                <a:solidFill>
+                  <a:srgbClr val="666666"/>
+                </a:solidFill>
+                <a:latin typeface="Microsoft YaHei"/>
+              </a:defRPr>
+            </a:pPr>
+            <a:r>
+              <a:t>floxml_tools 工作交接  |  2026-06-01</a:t>
+            </a:r>
+          </a:p>
+        </p:txBody>
+      </p:sp>
+    </p:spTree>
+  </p:cSld>
+  <p:clrMapOvr>
+    <a:masterClrMapping/>
+  </p:clrMapOvr>
+</p:sld>
+</file>
+
+<file path=ppt/slides/slide18.xml><?xml version="1.0" encoding="utf-8"?>
 <p:sld xmlns:a="http://schemas.openxmlformats.org/drawingml/2006/main" xmlns:p="http://schemas.openxmlformats.org/presentationml/2006/main" xmlns:r="http://schemas.openxmlformats.org/officeDocument/2006/relationships">
   <p:cSld>
     <p:bg>

</xml_diff>